<commit_message>
idea.html -> academic paper format (abstract/sections/eqs/Fig1/refs); build FEP-RLVE poster into poster模板.pptx (A0 portrait, title + 5 panels + figure)
Co-Authored-By: Claude Opus 4.8 <noreply@anthropic.com>
</commit_message>
<xml_diff>
--- a/poster模板.pptx
+++ b/poster模板.pptx
@@ -2970,84 +2970,1447 @@
       </p:grpSpPr>
       <p:sp>
         <p:nvSpPr>
-          <p:cNvPr id="2" name="标题 1">
-            <a:extLst>
-              <a:ext uri="{FF2B5EF4-FFF2-40B4-BE49-F238E27FC236}">
-                <a16:creationId xmlns:a16="http://schemas.microsoft.com/office/drawing/2014/main" id="{9F1021FD-3383-751E-28F4-5304CC8A7DA7}"/>
-              </a:ext>
-            </a:extLst>
-          </p:cNvPr>
-          <p:cNvSpPr>
-            <a:spLocks noGrp="1"/>
-          </p:cNvSpPr>
-          <p:nvPr>
-            <p:ph type="ctrTitle"/>
-          </p:nvPr>
-        </p:nvSpPr>
-        <p:spPr/>
-        <p:txBody>
-          <a:bodyPr/>
-          <a:lstStyle/>
-          <a:p>
-            <a:endParaRPr kumimoji="1" lang="zh-CN" altLang="en-US"/>
-          </a:p>
-        </p:txBody>
-      </p:sp>
-      <p:sp>
-        <p:nvSpPr>
-          <p:cNvPr id="3" name="副标题 2">
-            <a:extLst>
-              <a:ext uri="{FF2B5EF4-FFF2-40B4-BE49-F238E27FC236}">
-                <a16:creationId xmlns:a16="http://schemas.microsoft.com/office/drawing/2014/main" id="{89D4A7D4-30C4-F7B7-7AE4-12881F5E924D}"/>
-              </a:ext>
-            </a:extLst>
-          </p:cNvPr>
-          <p:cNvSpPr>
-            <a:spLocks noGrp="1"/>
-          </p:cNvSpPr>
-          <p:nvPr>
-            <p:ph type="subTitle" idx="1"/>
-          </p:nvPr>
-        </p:nvSpPr>
-        <p:spPr/>
-        <p:txBody>
-          <a:bodyPr/>
-          <a:lstStyle/>
-          <a:p>
-            <a:endParaRPr kumimoji="1" lang="zh-CN" altLang="en-US"/>
+          <p:cNvPr id="2" name="Rectangle 1"/>
+          <p:cNvSpPr/>
+          <p:nvPr/>
+        </p:nvSpPr>
+        <p:spPr>
+          <a:xfrm>
+            <a:off x="0" y="0"/>
+            <a:ext cx="21599525" cy="2834640"/>
+          </a:xfrm>
+          <a:prstGeom prst="rect">
+            <a:avLst/>
+          </a:prstGeom>
+          <a:solidFill>
+            <a:srgbClr val="0F1626"/>
+          </a:solidFill>
+          <a:ln>
+            <a:noFill/>
+          </a:ln>
+          <a:effectLst/>
+        </p:spPr>
+        <p:style>
+          <a:lnRef idx="1">
+            <a:schemeClr val="accent1"/>
+          </a:lnRef>
+          <a:fillRef idx="3">
+            <a:schemeClr val="accent1"/>
+          </a:fillRef>
+          <a:effectRef idx="2">
+            <a:schemeClr val="accent1"/>
+          </a:effectRef>
+          <a:fontRef idx="minor">
+            <a:schemeClr val="lt1"/>
+          </a:fontRef>
+        </p:style>
+        <p:txBody>
+          <a:bodyPr rtlCol="0" anchor="ctr"/>
+          <a:lstStyle/>
+          <a:p>
+            <a:pPr algn="ctr"/>
+          </a:p>
+        </p:txBody>
+      </p:sp>
+      <p:sp>
+        <p:nvSpPr>
+          <p:cNvPr id="3" name="TextBox 2"/>
+          <p:cNvSpPr txBox="1"/>
+          <p:nvPr/>
+        </p:nvSpPr>
+        <p:spPr>
+          <a:xfrm>
+            <a:off x="548640" y="320040"/>
+            <a:ext cx="20502245" cy="1371600"/>
+          </a:xfrm>
+          <a:prstGeom prst="rect">
+            <a:avLst/>
+          </a:prstGeom>
+          <a:noFill/>
+        </p:spPr>
+        <p:txBody>
+          <a:bodyPr wrap="square" anchor="t" lIns="60000" rIns="60000" tIns="30000" bIns="30000">
+            <a:spAutoFit/>
+          </a:bodyPr>
+          <a:lstStyle/>
+          <a:p>
+            <a:pPr algn="ctr">
+              <a:lnSpc>
+                <a:spcPct val="100000"/>
+              </a:lnSpc>
+            </a:pPr>
+            <a:r>
+              <a:rPr sz="4000" b="1">
+                <a:solidFill>
+                  <a:srgbClr val="FFFFFF"/>
+                </a:solidFill>
+                <a:latin typeface="Arial"/>
+              </a:rPr>
+              <a:t>FEP-RLVE: Expected-Free-Energy Difficulty Selection</a:t>
+            </a:r>
+          </a:p>
+          <a:p>
+            <a:pPr algn="ctr">
+              <a:lnSpc>
+                <a:spcPct val="100000"/>
+              </a:lnSpc>
+            </a:pPr>
+            <a:r>
+              <a:rPr sz="4000" b="1">
+                <a:solidFill>
+                  <a:srgbClr val="FFFFFF"/>
+                </a:solidFill>
+                <a:latin typeface="Arial"/>
+              </a:rPr>
+              <a:t>for Adaptive Verifiable Environments</a:t>
+            </a:r>
+          </a:p>
+        </p:txBody>
+      </p:sp>
+      <p:sp>
+        <p:nvSpPr>
+          <p:cNvPr id="4" name="TextBox 3"/>
+          <p:cNvSpPr txBox="1"/>
+          <p:nvPr/>
+        </p:nvSpPr>
+        <p:spPr>
+          <a:xfrm>
+            <a:off x="548640" y="1828800"/>
+            <a:ext cx="20502245" cy="822960"/>
+          </a:xfrm>
+          <a:prstGeom prst="rect">
+            <a:avLst/>
+          </a:prstGeom>
+          <a:noFill/>
+        </p:spPr>
+        <p:txBody>
+          <a:bodyPr wrap="square" anchor="t" lIns="60000" rIns="60000" tIns="30000" bIns="30000">
+            <a:spAutoFit/>
+          </a:bodyPr>
+          <a:lstStyle/>
+          <a:p>
+            <a:pPr algn="ctr">
+              <a:lnSpc>
+                <a:spcPct val="100000"/>
+              </a:lnSpc>
+            </a:pPr>
+            <a:r>
+              <a:rPr sz="2200" b="0">
+                <a:solidFill>
+                  <a:srgbClr val="C7CEE0"/>
+                </a:solidFill>
+                <a:latin typeface="Arial"/>
+              </a:rPr>
+              <a:t>Curriculum by inference, not by rule</a:t>
+            </a:r>
+          </a:p>
+          <a:p>
+            <a:pPr algn="ctr">
+              <a:lnSpc>
+                <a:spcPct val="100000"/>
+              </a:lnSpc>
+            </a:pPr>
+            <a:r>
+              <a:rPr sz="1600" b="0">
+                <a:solidFill>
+                  <a:srgbClr val="9BA6C2"/>
+                </a:solidFill>
+                <a:latin typeface="Arial"/>
+              </a:rPr>
+              <a:t>〈Your Name〉  ·  RL for LLM Reasoning with Environment Scaling  ·  baseline: RLVE (arXiv:2511.07317)</a:t>
+            </a:r>
+          </a:p>
+        </p:txBody>
+      </p:sp>
+      <p:sp>
+        <p:nvSpPr>
+          <p:cNvPr id="5" name="Rectangle 4"/>
+          <p:cNvSpPr/>
+          <p:nvPr/>
+        </p:nvSpPr>
+        <p:spPr>
+          <a:xfrm>
+            <a:off x="548640" y="3200400"/>
+            <a:ext cx="10022522" cy="3931920"/>
+          </a:xfrm>
+          <a:prstGeom prst="rect">
+            <a:avLst/>
+          </a:prstGeom>
+          <a:solidFill>
+            <a:srgbClr val="F4F2EE"/>
+          </a:solidFill>
+          <a:ln w="12700">
+            <a:solidFill>
+              <a:srgbClr val="D9D9D9"/>
+            </a:solidFill>
+          </a:ln>
+          <a:effectLst/>
+        </p:spPr>
+        <p:style>
+          <a:lnRef idx="1">
+            <a:schemeClr val="accent1"/>
+          </a:lnRef>
+          <a:fillRef idx="3">
+            <a:schemeClr val="accent1"/>
+          </a:fillRef>
+          <a:effectRef idx="2">
+            <a:schemeClr val="accent1"/>
+          </a:effectRef>
+          <a:fontRef idx="minor">
+            <a:schemeClr val="lt1"/>
+          </a:fontRef>
+        </p:style>
+        <p:txBody>
+          <a:bodyPr rtlCol="0" anchor="ctr"/>
+          <a:lstStyle/>
+          <a:p>
+            <a:pPr algn="ctr"/>
+          </a:p>
+        </p:txBody>
+      </p:sp>
+      <p:sp>
+        <p:nvSpPr>
+          <p:cNvPr id="6" name="TextBox 5"/>
+          <p:cNvSpPr txBox="1"/>
+          <p:nvPr/>
+        </p:nvSpPr>
+        <p:spPr>
+          <a:xfrm>
+            <a:off x="548640" y="3310128"/>
+            <a:ext cx="10022522" cy="548640"/>
+          </a:xfrm>
+          <a:prstGeom prst="rect">
+            <a:avLst/>
+          </a:prstGeom>
+          <a:noFill/>
+        </p:spPr>
+        <p:txBody>
+          <a:bodyPr wrap="square" anchor="t" lIns="60000" rIns="60000" tIns="30000" bIns="30000">
+            <a:spAutoFit/>
+          </a:bodyPr>
+          <a:lstStyle/>
+          <a:p>
+            <a:pPr algn="l">
+              <a:lnSpc>
+                <a:spcPct val="100000"/>
+              </a:lnSpc>
+            </a:pPr>
+            <a:r>
+              <a:rPr sz="2400" b="1">
+                <a:solidFill>
+                  <a:srgbClr val="C0392B"/>
+                </a:solidFill>
+                <a:latin typeface="Arial"/>
+              </a:rPr>
+              <a:t>1 · Problem</a:t>
+            </a:r>
+          </a:p>
+        </p:txBody>
+      </p:sp>
+      <p:sp>
+        <p:nvSpPr>
+          <p:cNvPr id="7" name="TextBox 6"/>
+          <p:cNvSpPr txBox="1"/>
+          <p:nvPr/>
+        </p:nvSpPr>
+        <p:spPr>
+          <a:xfrm>
+            <a:off x="548640" y="3886200"/>
+            <a:ext cx="10022522" cy="3154680"/>
+          </a:xfrm>
+          <a:prstGeom prst="rect">
+            <a:avLst/>
+          </a:prstGeom>
+          <a:noFill/>
+        </p:spPr>
+        <p:txBody>
+          <a:bodyPr wrap="square" anchor="t" lIns="60000" rIns="60000" tIns="30000" bIns="30000">
+            <a:spAutoFit/>
+          </a:bodyPr>
+          <a:lstStyle/>
+          <a:p>
+            <a:pPr algn="l">
+              <a:lnSpc>
+                <a:spcPct val="105000"/>
+              </a:lnSpc>
+            </a:pPr>
+            <a:r>
+              <a:rPr sz="1700" b="1">
+                <a:solidFill>
+                  <a:srgbClr val="161F37"/>
+                </a:solidFill>
+                <a:latin typeface="Arial"/>
+              </a:rPr>
+              <a:t>RL stalls when difficulty drifts off the model's frontier:</a:t>
+            </a:r>
+          </a:p>
+          <a:p>
+            <a:pPr algn="l">
+              <a:lnSpc>
+                <a:spcPct val="105000"/>
+              </a:lnSpc>
+            </a:pPr>
+            <a:r>
+              <a:rPr sz="1600" b="0">
+                <a:solidFill>
+                  <a:srgbClr val="161F37"/>
+                </a:solidFill>
+                <a:latin typeface="Arial"/>
+              </a:rPr>
+              <a:t>• too easy → group all-correct → 0 gradient</a:t>
+            </a:r>
+          </a:p>
+          <a:p>
+            <a:pPr algn="l">
+              <a:lnSpc>
+                <a:spcPct val="105000"/>
+              </a:lnSpc>
+            </a:pPr>
+            <a:r>
+              <a:rPr sz="1600" b="0">
+                <a:solidFill>
+                  <a:srgbClr val="161F37"/>
+                </a:solidFill>
+                <a:latin typeface="Arial"/>
+              </a:rPr>
+              <a:t>• too hard → group all-wrong → 0 gradient</a:t>
+            </a:r>
+          </a:p>
+          <a:p>
+            <a:pPr algn="l">
+              <a:lnSpc>
+                <a:spcPct val="105000"/>
+              </a:lnSpc>
+            </a:pPr>
+            <a:r>
+              <a:rPr sz="1600" b="0">
+                <a:solidFill>
+                  <a:srgbClr val="161F37"/>
+                </a:solidFill>
+                <a:latin typeface="Arial"/>
+              </a:rPr>
+              <a:t>Signal of a K-rollout group = U_K(p)=1−p^K−(1−p)^K,</a:t>
+            </a:r>
+          </a:p>
+          <a:p>
+            <a:pPr algn="l">
+              <a:lnSpc>
+                <a:spcPct val="105000"/>
+              </a:lnSpc>
+            </a:pPr>
+            <a:r>
+              <a:rPr sz="1600" b="1">
+                <a:solidFill>
+                  <a:srgbClr val="C0392B"/>
+                </a:solidFill>
+                <a:latin typeface="Arial"/>
+              </a:rPr>
+              <a:t>maximal at success p = 0.5.</a:t>
+            </a:r>
+          </a:p>
+          <a:p>
+            <a:pPr algn="l">
+              <a:lnSpc>
+                <a:spcPct val="105000"/>
+              </a:lnSpc>
+            </a:pPr>
+            <a:r>
+              <a:rPr sz="1600" b="0">
+                <a:solidFill>
+                  <a:srgbClr val="161F37"/>
+                </a:solidFill>
+                <a:latin typeface="Arial"/>
+              </a:rPr>
+              <a:t>RLVE raises difficulty only at acc ≥ 0.9 → sits at</a:t>
+            </a:r>
+          </a:p>
+          <a:p>
+            <a:pPr algn="l">
+              <a:lnSpc>
+                <a:spcPct val="105000"/>
+              </a:lnSpc>
+            </a:pPr>
+            <a:r>
+              <a:rPr sz="1600" b="1">
+                <a:solidFill>
+                  <a:srgbClr val="C0392B"/>
+                </a:solidFill>
+                <a:latin typeface="Arial"/>
+              </a:rPr>
+              <a:t>U_K(0.9)≈0.57 ≪ U_K(0.5)≈0.99 : a low-signal regime.</a:t>
+            </a:r>
+          </a:p>
+        </p:txBody>
+      </p:sp>
+      <p:sp>
+        <p:nvSpPr>
+          <p:cNvPr id="8" name="Rectangle 7"/>
+          <p:cNvSpPr/>
+          <p:nvPr/>
+        </p:nvSpPr>
+        <p:spPr>
+          <a:xfrm>
+            <a:off x="548640" y="7498080"/>
+            <a:ext cx="10022522" cy="5120640"/>
+          </a:xfrm>
+          <a:prstGeom prst="rect">
+            <a:avLst/>
+          </a:prstGeom>
+          <a:solidFill>
+            <a:srgbClr val="F4F2EE"/>
+          </a:solidFill>
+          <a:ln w="12700">
+            <a:solidFill>
+              <a:srgbClr val="D9D9D9"/>
+            </a:solidFill>
+          </a:ln>
+          <a:effectLst/>
+        </p:spPr>
+        <p:style>
+          <a:lnRef idx="1">
+            <a:schemeClr val="accent1"/>
+          </a:lnRef>
+          <a:fillRef idx="3">
+            <a:schemeClr val="accent1"/>
+          </a:fillRef>
+          <a:effectRef idx="2">
+            <a:schemeClr val="accent1"/>
+          </a:effectRef>
+          <a:fontRef idx="minor">
+            <a:schemeClr val="lt1"/>
+          </a:fontRef>
+        </p:style>
+        <p:txBody>
+          <a:bodyPr rtlCol="0" anchor="ctr"/>
+          <a:lstStyle/>
+          <a:p>
+            <a:pPr algn="ctr"/>
+          </a:p>
+        </p:txBody>
+      </p:sp>
+      <p:sp>
+        <p:nvSpPr>
+          <p:cNvPr id="9" name="TextBox 8"/>
+          <p:cNvSpPr txBox="1"/>
+          <p:nvPr/>
+        </p:nvSpPr>
+        <p:spPr>
+          <a:xfrm>
+            <a:off x="548640" y="7607808"/>
+            <a:ext cx="10022522" cy="548640"/>
+          </a:xfrm>
+          <a:prstGeom prst="rect">
+            <a:avLst/>
+          </a:prstGeom>
+          <a:noFill/>
+        </p:spPr>
+        <p:txBody>
+          <a:bodyPr wrap="square" anchor="t" lIns="60000" rIns="60000" tIns="30000" bIns="30000">
+            <a:spAutoFit/>
+          </a:bodyPr>
+          <a:lstStyle/>
+          <a:p>
+            <a:pPr algn="l">
+              <a:lnSpc>
+                <a:spcPct val="100000"/>
+              </a:lnSpc>
+            </a:pPr>
+            <a:r>
+              <a:rPr sz="2400" b="1">
+                <a:solidFill>
+                  <a:srgbClr val="C0392B"/>
+                </a:solidFill>
+                <a:latin typeface="Arial"/>
+              </a:rPr>
+              <a:t>2 · Method — minimize Expected Free Energy</a:t>
+            </a:r>
+          </a:p>
+        </p:txBody>
+      </p:sp>
+      <p:sp>
+        <p:nvSpPr>
+          <p:cNvPr id="10" name="TextBox 9"/>
+          <p:cNvSpPr txBox="1"/>
+          <p:nvPr/>
+        </p:nvSpPr>
+        <p:spPr>
+          <a:xfrm>
+            <a:off x="548640" y="8183880"/>
+            <a:ext cx="10022522" cy="4343400"/>
+          </a:xfrm>
+          <a:prstGeom prst="rect">
+            <a:avLst/>
+          </a:prstGeom>
+          <a:noFill/>
+        </p:spPr>
+        <p:txBody>
+          <a:bodyPr wrap="square" anchor="t" lIns="60000" rIns="60000" tIns="30000" bIns="30000">
+            <a:spAutoFit/>
+          </a:bodyPr>
+          <a:lstStyle/>
+          <a:p>
+            <a:pPr algn="l">
+              <a:lnSpc>
+                <a:spcPct val="105000"/>
+              </a:lnSpc>
+            </a:pPr>
+            <a:r>
+              <a:rPr sz="1600" b="1">
+                <a:solidFill>
+                  <a:srgbClr val="161F37"/>
+                </a:solidFill>
+                <a:latin typeface="Arial"/>
+              </a:rPr>
+              <a:t>Treat 'which difficulty to train on' as ACTION SELECTION</a:t>
+            </a:r>
+          </a:p>
+          <a:p>
+            <a:pPr algn="l">
+              <a:lnSpc>
+                <a:spcPct val="105000"/>
+              </a:lnSpc>
+            </a:pPr>
+            <a:r>
+              <a:rPr sz="1500" b="0">
+                <a:solidFill>
+                  <a:srgbClr val="161F37"/>
+                </a:solidFill>
+                <a:latin typeface="Arial"/>
+              </a:rPr>
+              <a:t>under the Free Energy Principle. Keep a belief q(s) over</a:t>
+            </a:r>
+          </a:p>
+          <a:p>
+            <a:pPr algn="l">
+              <a:lnSpc>
+                <a:spcPct val="105000"/>
+              </a:lnSpc>
+            </a:pPr>
+            <a:r>
+              <a:rPr sz="1500" b="0">
+                <a:solidFill>
+                  <a:srgbClr val="161F37"/>
+                </a:solidFill>
+                <a:latin typeface="Arial"/>
+              </a:rPr>
+              <a:t>the model's latent competence; pick d by minimizing EFE:</a:t>
+            </a:r>
+          </a:p>
+          <a:p>
+            <a:pPr algn="l">
+              <a:lnSpc>
+                <a:spcPct val="105000"/>
+              </a:lnSpc>
+            </a:pPr>
+            <a:r>
+              <a:rPr sz="1600" b="1">
+                <a:solidFill>
+                  <a:srgbClr val="2C6E8F"/>
+                </a:solidFill>
+                <a:latin typeface="Arial"/>
+              </a:rPr>
+              <a:t>  G(d) = −λ_sig·U_K(p̂) − λ_info·I(s;o|d) + λ_cost·C(d)</a:t>
+            </a:r>
+          </a:p>
+          <a:p>
+            <a:pPr algn="l">
+              <a:lnSpc>
+                <a:spcPct val="105000"/>
+              </a:lnSpc>
+            </a:pPr>
+            <a:r>
+              <a:rPr sz="1600" b="1">
+                <a:solidFill>
+                  <a:srgbClr val="2C6E8F"/>
+                </a:solidFill>
+                <a:latin typeface="Arial"/>
+              </a:rPr>
+              <a:t>  π(d) ∝ exp(−G(d)/T)</a:t>
+            </a:r>
+          </a:p>
+          <a:p>
+            <a:pPr algn="l">
+              <a:lnSpc>
+                <a:spcPct val="105000"/>
+              </a:lnSpc>
+            </a:pPr>
+            <a:r>
+              <a:rPr sz="1500" b="1">
+                <a:solidFill>
+                  <a:srgbClr val="C0392B"/>
+                </a:solidFill>
+                <a:latin typeface="Arial"/>
+              </a:rPr>
+              <a:t>pragmatic U_K : the DAPO learning signal (peak 0.5)</a:t>
+            </a:r>
+          </a:p>
+          <a:p>
+            <a:pPr algn="l">
+              <a:lnSpc>
+                <a:spcPct val="105000"/>
+              </a:lnSpc>
+            </a:pPr>
+            <a:r>
+              <a:rPr sz="1500" b="1">
+                <a:solidFill>
+                  <a:srgbClr val="2C6E8F"/>
+                </a:solidFill>
+                <a:latin typeface="Arial"/>
+              </a:rPr>
+              <a:t>epistemic I(s;o|d): info gain about competence (peak 0.5)</a:t>
+            </a:r>
+          </a:p>
+          <a:p>
+            <a:pPr algn="l">
+              <a:lnSpc>
+                <a:spcPct val="105000"/>
+              </a:lnSpc>
+            </a:pPr>
+            <a:r>
+              <a:rPr sz="1500" b="0">
+                <a:solidFill>
+                  <a:srgbClr val="161F37"/>
+                </a:solidFill>
+                <a:latin typeface="Arial"/>
+              </a:rPr>
+              <a:t>T→0 ⇒ hard set-point at optimal 0.5 (vs RLVE's 0.9);</a:t>
+            </a:r>
+          </a:p>
+          <a:p>
+            <a:pPr algn="l">
+              <a:lnSpc>
+                <a:spcPct val="105000"/>
+              </a:lnSpc>
+            </a:pPr>
+            <a:r>
+              <a:rPr sz="1500" b="0">
+                <a:solidFill>
+                  <a:srgbClr val="161F37"/>
+                </a:solidFill>
+                <a:latin typeface="Arial"/>
+              </a:rPr>
+              <a:t>uncertain belief ⇒ explore; localized ⇒ exploit (auto).</a:t>
+            </a:r>
+          </a:p>
+          <a:p>
+            <a:pPr algn="l">
+              <a:lnSpc>
+                <a:spcPct val="105000"/>
+              </a:lnSpc>
+            </a:pPr>
+            <a:r>
+              <a:rPr sz="1500" b="0">
+                <a:solidFill>
+                  <a:srgbClr val="161F37"/>
+                </a:solidFill>
+                <a:latin typeface="Arial"/>
+              </a:rPr>
+              <a:t>IRT belief σ(a(s−d)), Bayesian update each rollout.</a:t>
+            </a:r>
+          </a:p>
+        </p:txBody>
+      </p:sp>
+      <p:sp>
+        <p:nvSpPr>
+          <p:cNvPr id="11" name="Rectangle 10"/>
+          <p:cNvSpPr/>
+          <p:nvPr/>
+        </p:nvSpPr>
+        <p:spPr>
+          <a:xfrm>
+            <a:off x="548640" y="12984480"/>
+            <a:ext cx="10022522" cy="3840480"/>
+          </a:xfrm>
+          <a:prstGeom prst="rect">
+            <a:avLst/>
+          </a:prstGeom>
+          <a:solidFill>
+            <a:srgbClr val="F4F2EE"/>
+          </a:solidFill>
+          <a:ln w="12700">
+            <a:solidFill>
+              <a:srgbClr val="D9D9D9"/>
+            </a:solidFill>
+          </a:ln>
+          <a:effectLst/>
+        </p:spPr>
+        <p:style>
+          <a:lnRef idx="1">
+            <a:schemeClr val="accent1"/>
+          </a:lnRef>
+          <a:fillRef idx="3">
+            <a:schemeClr val="accent1"/>
+          </a:fillRef>
+          <a:effectRef idx="2">
+            <a:schemeClr val="accent1"/>
+          </a:effectRef>
+          <a:fontRef idx="minor">
+            <a:schemeClr val="lt1"/>
+          </a:fontRef>
+        </p:style>
+        <p:txBody>
+          <a:bodyPr rtlCol="0" anchor="ctr"/>
+          <a:lstStyle/>
+          <a:p>
+            <a:pPr algn="ctr"/>
+          </a:p>
+        </p:txBody>
+      </p:sp>
+      <p:sp>
+        <p:nvSpPr>
+          <p:cNvPr id="12" name="TextBox 11"/>
+          <p:cNvSpPr txBox="1"/>
+          <p:nvPr/>
+        </p:nvSpPr>
+        <p:spPr>
+          <a:xfrm>
+            <a:off x="548640" y="13094208"/>
+            <a:ext cx="10022522" cy="548640"/>
+          </a:xfrm>
+          <a:prstGeom prst="rect">
+            <a:avLst/>
+          </a:prstGeom>
+          <a:noFill/>
+        </p:spPr>
+        <p:txBody>
+          <a:bodyPr wrap="square" anchor="t" lIns="60000" rIns="60000" tIns="30000" bIns="30000">
+            <a:spAutoFit/>
+          </a:bodyPr>
+          <a:lstStyle/>
+          <a:p>
+            <a:pPr algn="l">
+              <a:lnSpc>
+                <a:spcPct val="100000"/>
+              </a:lnSpc>
+            </a:pPr>
+            <a:r>
+              <a:rPr sz="2400" b="1">
+                <a:solidFill>
+                  <a:srgbClr val="C0392B"/>
+                </a:solidFill>
+                <a:latin typeface="Arial"/>
+              </a:rPr>
+              <a:t>3 · Setup</a:t>
+            </a:r>
+          </a:p>
+        </p:txBody>
+      </p:sp>
+      <p:sp>
+        <p:nvSpPr>
+          <p:cNvPr id="13" name="TextBox 12"/>
+          <p:cNvSpPr txBox="1"/>
+          <p:nvPr/>
+        </p:nvSpPr>
+        <p:spPr>
+          <a:xfrm>
+            <a:off x="548640" y="13670280"/>
+            <a:ext cx="10022522" cy="3063240"/>
+          </a:xfrm>
+          <a:prstGeom prst="rect">
+            <a:avLst/>
+          </a:prstGeom>
+          <a:noFill/>
+        </p:spPr>
+        <p:txBody>
+          <a:bodyPr wrap="square" anchor="t" lIns="60000" rIns="60000" tIns="30000" bIns="30000">
+            <a:spAutoFit/>
+          </a:bodyPr>
+          <a:lstStyle/>
+          <a:p>
+            <a:pPr algn="l">
+              <a:lnSpc>
+                <a:spcPct val="105000"/>
+              </a:lnSpc>
+            </a:pPr>
+            <a:r>
+              <a:rPr sz="1600" b="1">
+                <a:solidFill>
+                  <a:srgbClr val="161F37"/>
+                </a:solidFill>
+                <a:latin typeface="Arial"/>
+              </a:rPr>
+              <a:t>Reproduce RLVE (SLIME) from ProRL-1.5B-v2, single H200.</a:t>
+            </a:r>
+          </a:p>
+          <a:p>
+            <a:pPr algn="l">
+              <a:lnSpc>
+                <a:spcPct val="105000"/>
+              </a:lnSpc>
+            </a:pPr>
+            <a:r>
+              <a:rPr sz="1500" b="0">
+                <a:solidFill>
+                  <a:srgbClr val="161F37"/>
+                </a:solidFill>
+                <a:latin typeface="Arial"/>
+              </a:rPr>
+              <a:t>RLVE-Gym verifiable envs + held-out envs. Same model,</a:t>
+            </a:r>
+          </a:p>
+          <a:p>
+            <a:pPr algn="l">
+              <a:lnSpc>
+                <a:spcPct val="105000"/>
+              </a:lnSpc>
+            </a:pPr>
+            <a:r>
+              <a:rPr sz="1500" b="0">
+                <a:solidFill>
+                  <a:srgbClr val="161F37"/>
+                </a:solidFill>
+                <a:latin typeface="Arial"/>
+              </a:rPr>
+              <a:t>compute, RL algo (DAPO); only the difficulty sampler differs.</a:t>
+            </a:r>
+          </a:p>
+          <a:p>
+            <a:pPr algn="l">
+              <a:lnSpc>
+                <a:spcPct val="105000"/>
+              </a:lnSpc>
+            </a:pPr>
+            <a:r>
+              <a:rPr sz="1500" b="0">
+                <a:solidFill>
+                  <a:srgbClr val="161F37"/>
+                </a:solidFill>
+                <a:latin typeface="Arial"/>
+              </a:rPr>
+              <a:t>Drop-in controller switched by DIFFICULTY_MODE; default</a:t>
+            </a:r>
+          </a:p>
+          <a:p>
+            <a:pPr algn="l">
+              <a:lnSpc>
+                <a:spcPct val="105000"/>
+              </a:lnSpc>
+            </a:pPr>
+            <a:r>
+              <a:rPr sz="1500" b="0">
+                <a:solidFill>
+                  <a:srgbClr val="161F37"/>
+                </a:solidFill>
+                <a:latin typeface="Arial"/>
+              </a:rPr>
+              <a:t>behavior is byte-for-byte RLVE.</a:t>
+            </a:r>
+          </a:p>
+        </p:txBody>
+      </p:sp>
+      <p:sp>
+        <p:nvSpPr>
+          <p:cNvPr id="14" name="Rectangle 13"/>
+          <p:cNvSpPr/>
+          <p:nvPr/>
+        </p:nvSpPr>
+        <p:spPr>
+          <a:xfrm>
+            <a:off x="11028362" y="3200400"/>
+            <a:ext cx="10022522" cy="4572000"/>
+          </a:xfrm>
+          <a:prstGeom prst="rect">
+            <a:avLst/>
+          </a:prstGeom>
+          <a:solidFill>
+            <a:srgbClr val="FFFFFF"/>
+          </a:solidFill>
+          <a:ln w="12700">
+            <a:solidFill>
+              <a:srgbClr val="D9D9D9"/>
+            </a:solidFill>
+          </a:ln>
+          <a:effectLst/>
+        </p:spPr>
+        <p:style>
+          <a:lnRef idx="1">
+            <a:schemeClr val="accent1"/>
+          </a:lnRef>
+          <a:fillRef idx="3">
+            <a:schemeClr val="accent1"/>
+          </a:fillRef>
+          <a:effectRef idx="2">
+            <a:schemeClr val="accent1"/>
+          </a:effectRef>
+          <a:fontRef idx="minor">
+            <a:schemeClr val="lt1"/>
+          </a:fontRef>
+        </p:style>
+        <p:txBody>
+          <a:bodyPr rtlCol="0" anchor="ctr"/>
+          <a:lstStyle/>
+          <a:p>
+            <a:pPr algn="ctr"/>
+          </a:p>
+        </p:txBody>
+      </p:sp>
+      <p:sp>
+        <p:nvSpPr>
+          <p:cNvPr id="15" name="TextBox 14"/>
+          <p:cNvSpPr txBox="1"/>
+          <p:nvPr/>
+        </p:nvSpPr>
+        <p:spPr>
+          <a:xfrm>
+            <a:off x="11028362" y="3310128"/>
+            <a:ext cx="10022522" cy="548640"/>
+          </a:xfrm>
+          <a:prstGeom prst="rect">
+            <a:avLst/>
+          </a:prstGeom>
+          <a:noFill/>
+        </p:spPr>
+        <p:txBody>
+          <a:bodyPr wrap="square" anchor="t" lIns="60000" rIns="60000" tIns="30000" bIns="30000">
+            <a:spAutoFit/>
+          </a:bodyPr>
+          <a:lstStyle/>
+          <a:p>
+            <a:pPr algn="l">
+              <a:lnSpc>
+                <a:spcPct val="100000"/>
+              </a:lnSpc>
+            </a:pPr>
+            <a:r>
+              <a:rPr sz="2400" b="1">
+                <a:solidFill>
+                  <a:srgbClr val="C0392B"/>
+                </a:solidFill>
+                <a:latin typeface="Arial"/>
+              </a:rPr>
+              <a:t>Key idea: both signals peak at p = 0.5</a:t>
+            </a:r>
           </a:p>
         </p:txBody>
       </p:sp>
       <p:pic>
         <p:nvPicPr>
-          <p:cNvPr id="5" name="图片 4" descr="形状&#10;&#10;中度可信度描述已自动生成">
-            <a:extLst>
-              <a:ext uri="{FF2B5EF4-FFF2-40B4-BE49-F238E27FC236}">
-                <a16:creationId xmlns:a16="http://schemas.microsoft.com/office/drawing/2014/main" id="{85F2C7CD-D641-AD77-DC02-00B782104AB8}"/>
-              </a:ext>
-            </a:extLst>
-          </p:cNvPr>
+          <p:cNvPr id="16" name="Picture 15" descr="poster_fig1.png"/>
           <p:cNvPicPr>
             <a:picLocks noChangeAspect="1"/>
           </p:cNvPicPr>
           <p:nvPr/>
         </p:nvPicPr>
         <p:blipFill>
-          <a:blip r:embed="rId2"/>
+          <a:blip r:embed="rId3"/>
           <a:stretch>
             <a:fillRect/>
           </a:stretch>
         </p:blipFill>
         <p:spPr>
           <a:xfrm>
-            <a:off x="-1" y="0"/>
-            <a:ext cx="21599525" cy="32399288"/>
+            <a:off x="11256962" y="3931920"/>
+            <a:ext cx="9565322" cy="5579771"/>
           </a:xfrm>
           <a:prstGeom prst="rect">
             <a:avLst/>
           </a:prstGeom>
         </p:spPr>
       </p:pic>
+      <p:sp>
+        <p:nvSpPr>
+          <p:cNvPr id="17" name="Rectangle 16"/>
+          <p:cNvSpPr/>
+          <p:nvPr/>
+        </p:nvSpPr>
+        <p:spPr>
+          <a:xfrm>
+            <a:off x="11028362" y="8138160"/>
+            <a:ext cx="10022522" cy="4937760"/>
+          </a:xfrm>
+          <a:prstGeom prst="rect">
+            <a:avLst/>
+          </a:prstGeom>
+          <a:solidFill>
+            <a:srgbClr val="F4F2EE"/>
+          </a:solidFill>
+          <a:ln w="12700">
+            <a:solidFill>
+              <a:srgbClr val="D9D9D9"/>
+            </a:solidFill>
+          </a:ln>
+          <a:effectLst/>
+        </p:spPr>
+        <p:style>
+          <a:lnRef idx="1">
+            <a:schemeClr val="accent1"/>
+          </a:lnRef>
+          <a:fillRef idx="3">
+            <a:schemeClr val="accent1"/>
+          </a:fillRef>
+          <a:effectRef idx="2">
+            <a:schemeClr val="accent1"/>
+          </a:effectRef>
+          <a:fontRef idx="minor">
+            <a:schemeClr val="lt1"/>
+          </a:fontRef>
+        </p:style>
+        <p:txBody>
+          <a:bodyPr rtlCol="0" anchor="ctr"/>
+          <a:lstStyle/>
+          <a:p>
+            <a:pPr algn="ctr"/>
+          </a:p>
+        </p:txBody>
+      </p:sp>
+      <p:sp>
+        <p:nvSpPr>
+          <p:cNvPr id="18" name="TextBox 17"/>
+          <p:cNvSpPr txBox="1"/>
+          <p:nvPr/>
+        </p:nvSpPr>
+        <p:spPr>
+          <a:xfrm>
+            <a:off x="11028362" y="8247888"/>
+            <a:ext cx="10022522" cy="548640"/>
+          </a:xfrm>
+          <a:prstGeom prst="rect">
+            <a:avLst/>
+          </a:prstGeom>
+          <a:noFill/>
+        </p:spPr>
+        <p:txBody>
+          <a:bodyPr wrap="square" anchor="t" lIns="60000" rIns="60000" tIns="30000" bIns="30000">
+            <a:spAutoFit/>
+          </a:bodyPr>
+          <a:lstStyle/>
+          <a:p>
+            <a:pPr algn="l">
+              <a:lnSpc>
+                <a:spcPct val="100000"/>
+              </a:lnSpc>
+            </a:pPr>
+            <a:r>
+              <a:rPr sz="2400" b="1">
+                <a:solidFill>
+                  <a:srgbClr val="C0392B"/>
+                </a:solidFill>
+                <a:latin typeface="Arial"/>
+              </a:rPr>
+              <a:t>4 · Four-arm comparison</a:t>
+            </a:r>
+          </a:p>
+        </p:txBody>
+      </p:sp>
+      <p:sp>
+        <p:nvSpPr>
+          <p:cNvPr id="19" name="TextBox 18"/>
+          <p:cNvSpPr txBox="1"/>
+          <p:nvPr/>
+        </p:nvSpPr>
+        <p:spPr>
+          <a:xfrm>
+            <a:off x="11028362" y="8823960"/>
+            <a:ext cx="10022522" cy="4160520"/>
+          </a:xfrm>
+          <a:prstGeom prst="rect">
+            <a:avLst/>
+          </a:prstGeom>
+          <a:noFill/>
+        </p:spPr>
+        <p:txBody>
+          <a:bodyPr wrap="square" anchor="t" lIns="60000" rIns="60000" tIns="30000" bIns="30000">
+            <a:spAutoFit/>
+          </a:bodyPr>
+          <a:lstStyle/>
+          <a:p>
+            <a:pPr algn="l">
+              <a:lnSpc>
+                <a:spcPct val="105000"/>
+              </a:lnSpc>
+            </a:pPr>
+            <a:r>
+              <a:rPr sz="1500" b="0">
+                <a:solidFill>
+                  <a:srgbClr val="161F37"/>
+                </a:solidFill>
+                <a:latin typeface="Arial"/>
+              </a:rPr>
+              <a:t>Static        frozen d        → fixed difficulty fails</a:t>
+            </a:r>
+          </a:p>
+          <a:p>
+            <a:pPr algn="l">
+              <a:lnSpc>
+                <a:spcPct val="105000"/>
+              </a:lnSpc>
+            </a:pPr>
+            <a:r>
+              <a:rPr sz="1500" b="0">
+                <a:solidFill>
+                  <a:srgbClr val="161F37"/>
+                </a:solidFill>
+                <a:latin typeface="Arial"/>
+              </a:rPr>
+              <a:t>RLVE-90       raise at 0.9     → baseline (low signal)</a:t>
+            </a:r>
+          </a:p>
+          <a:p>
+            <a:pPr algn="l">
+              <a:lnSpc>
+                <a:spcPct val="105000"/>
+              </a:lnSpc>
+            </a:pPr>
+            <a:r>
+              <a:rPr sz="1500" b="0">
+                <a:solidFill>
+                  <a:srgbClr val="161F37"/>
+                </a:solidFill>
+                <a:latin typeface="Arial"/>
+              </a:rPr>
+              <a:t>Signal-RLVE   U_K only         → 0.5 band, no info gain</a:t>
+            </a:r>
+          </a:p>
+          <a:p>
+            <a:pPr algn="l">
+              <a:lnSpc>
+                <a:spcPct val="105000"/>
+              </a:lnSpc>
+            </a:pPr>
+            <a:r>
+              <a:rPr sz="1500" b="1">
+                <a:solidFill>
+                  <a:srgbClr val="C0392B"/>
+                </a:solidFill>
+                <a:latin typeface="Arial"/>
+              </a:rPr>
+              <a:t>FEP-RLVE      U_K + info + EFE → full active inference</a:t>
+            </a:r>
+          </a:p>
+          <a:p>
+            <a:pPr algn="l">
+              <a:lnSpc>
+                <a:spcPct val="105000"/>
+              </a:lnSpc>
+            </a:pPr>
+            <a:r>
+              <a:rPr sz="800" b="0">
+                <a:solidFill>
+                  <a:srgbClr val="161F37"/>
+                </a:solidFill>
+                <a:latin typeface="Arial"/>
+              </a:rPr>
+              <a:t> </a:t>
+            </a:r>
+          </a:p>
+          <a:p>
+            <a:pPr algn="l">
+              <a:lnSpc>
+                <a:spcPct val="105000"/>
+              </a:lnSpc>
+            </a:pPr>
+            <a:r>
+              <a:rPr sz="1500" b="1">
+                <a:solidFill>
+                  <a:srgbClr val="161F37"/>
+                </a:solidFill>
+                <a:latin typeface="Arial"/>
+              </a:rPr>
+              <a:t>Signal-RLVE is the key ablation: only if FEP-RLVE beats it</a:t>
+            </a:r>
+          </a:p>
+          <a:p>
+            <a:pPr algn="l">
+              <a:lnSpc>
+                <a:spcPct val="105000"/>
+              </a:lnSpc>
+            </a:pPr>
+            <a:r>
+              <a:rPr sz="1500" b="0">
+                <a:solidFill>
+                  <a:srgbClr val="161F37"/>
+                </a:solidFill>
+                <a:latin typeface="Arial"/>
+              </a:rPr>
+              <a:t>does the epistemic info-gain (the FEP core) demonstrably</a:t>
+            </a:r>
+          </a:p>
+          <a:p>
+            <a:pPr algn="l">
+              <a:lnSpc>
+                <a:spcPct val="105000"/>
+              </a:lnSpc>
+            </a:pPr>
+            <a:r>
+              <a:rPr sz="1500" b="0">
+                <a:solidFill>
+                  <a:srgbClr val="161F37"/>
+                </a:solidFill>
+                <a:latin typeface="Arial"/>
+              </a:rPr>
+              <a:t>help — not just 'replace 0.9 with 0.5'.</a:t>
+            </a:r>
+          </a:p>
+          <a:p>
+            <a:pPr algn="l">
+              <a:lnSpc>
+                <a:spcPct val="105000"/>
+              </a:lnSpc>
+            </a:pPr>
+            <a:r>
+              <a:rPr sz="800" b="0">
+                <a:solidFill>
+                  <a:srgbClr val="161F37"/>
+                </a:solidFill>
+                <a:latin typeface="Arial"/>
+              </a:rPr>
+              <a:t> </a:t>
+            </a:r>
+          </a:p>
+          <a:p>
+            <a:pPr algn="l">
+              <a:lnSpc>
+                <a:spcPct val="105000"/>
+              </a:lnSpc>
+            </a:pPr>
+            <a:r>
+              <a:rPr sz="1500" b="0">
+                <a:solidFill>
+                  <a:srgbClr val="161F37"/>
+                </a:solidFill>
+                <a:latin typeface="Arial"/>
+              </a:rPr>
+              <a:t>Metrics: effective sample ratio · competence-belief</a:t>
+            </a:r>
+          </a:p>
+          <a:p>
+            <a:pPr algn="l">
+              <a:lnSpc>
+                <a:spcPct val="105000"/>
+              </a:lnSpc>
+            </a:pPr>
+            <a:r>
+              <a:rPr sz="1500" b="0">
+                <a:solidFill>
+                  <a:srgbClr val="161F37"/>
+                </a:solidFill>
+                <a:latin typeface="Arial"/>
+              </a:rPr>
+              <a:t>trajectory · held-out generalization (before/after).</a:t>
+            </a:r>
+          </a:p>
+        </p:txBody>
+      </p:sp>
+      <p:sp>
+        <p:nvSpPr>
+          <p:cNvPr id="20" name="Rectangle 19"/>
+          <p:cNvSpPr/>
+          <p:nvPr/>
+        </p:nvSpPr>
+        <p:spPr>
+          <a:xfrm>
+            <a:off x="11028362" y="13441680"/>
+            <a:ext cx="10022522" cy="3840480"/>
+          </a:xfrm>
+          <a:prstGeom prst="rect">
+            <a:avLst/>
+          </a:prstGeom>
+          <a:solidFill>
+            <a:srgbClr val="F4F2EE"/>
+          </a:solidFill>
+          <a:ln w="12700">
+            <a:solidFill>
+              <a:srgbClr val="D9D9D9"/>
+            </a:solidFill>
+          </a:ln>
+          <a:effectLst/>
+        </p:spPr>
+        <p:style>
+          <a:lnRef idx="1">
+            <a:schemeClr val="accent1"/>
+          </a:lnRef>
+          <a:fillRef idx="3">
+            <a:schemeClr val="accent1"/>
+          </a:fillRef>
+          <a:effectRef idx="2">
+            <a:schemeClr val="accent1"/>
+          </a:effectRef>
+          <a:fontRef idx="minor">
+            <a:schemeClr val="lt1"/>
+          </a:fontRef>
+        </p:style>
+        <p:txBody>
+          <a:bodyPr rtlCol="0" anchor="ctr"/>
+          <a:lstStyle/>
+          <a:p>
+            <a:pPr algn="ctr"/>
+          </a:p>
+        </p:txBody>
+      </p:sp>
+      <p:sp>
+        <p:nvSpPr>
+          <p:cNvPr id="21" name="TextBox 20"/>
+          <p:cNvSpPr txBox="1"/>
+          <p:nvPr/>
+        </p:nvSpPr>
+        <p:spPr>
+          <a:xfrm>
+            <a:off x="11028362" y="13551408"/>
+            <a:ext cx="10022522" cy="548640"/>
+          </a:xfrm>
+          <a:prstGeom prst="rect">
+            <a:avLst/>
+          </a:prstGeom>
+          <a:noFill/>
+        </p:spPr>
+        <p:txBody>
+          <a:bodyPr wrap="square" anchor="t" lIns="60000" rIns="60000" tIns="30000" bIns="30000">
+            <a:spAutoFit/>
+          </a:bodyPr>
+          <a:lstStyle/>
+          <a:p>
+            <a:pPr algn="l">
+              <a:lnSpc>
+                <a:spcPct val="100000"/>
+              </a:lnSpc>
+            </a:pPr>
+            <a:r>
+              <a:rPr sz="2400" b="1">
+                <a:solidFill>
+                  <a:srgbClr val="C0392B"/>
+                </a:solidFill>
+                <a:latin typeface="Arial"/>
+              </a:rPr>
+              <a:t>5 · Takeaways</a:t>
+            </a:r>
+          </a:p>
+        </p:txBody>
+      </p:sp>
+      <p:sp>
+        <p:nvSpPr>
+          <p:cNvPr id="22" name="TextBox 21"/>
+          <p:cNvSpPr txBox="1"/>
+          <p:nvPr/>
+        </p:nvSpPr>
+        <p:spPr>
+          <a:xfrm>
+            <a:off x="11028362" y="14127480"/>
+            <a:ext cx="10022522" cy="3063240"/>
+          </a:xfrm>
+          <a:prstGeom prst="rect">
+            <a:avLst/>
+          </a:prstGeom>
+          <a:noFill/>
+        </p:spPr>
+        <p:txBody>
+          <a:bodyPr wrap="square" anchor="t" lIns="60000" rIns="60000" tIns="30000" bIns="30000">
+            <a:spAutoFit/>
+          </a:bodyPr>
+          <a:lstStyle/>
+          <a:p>
+            <a:pPr algn="l">
+              <a:lnSpc>
+                <a:spcPct val="105000"/>
+              </a:lnSpc>
+            </a:pPr>
+            <a:r>
+              <a:rPr sz="1600" b="1">
+                <a:solidFill>
+                  <a:srgbClr val="161F37"/>
+                </a:solidFill>
+                <a:latin typeface="Arial"/>
+              </a:rPr>
+              <a:t>• Difficulty = a control target (EFE), not a 0.9 threshold.</a:t>
+            </a:r>
+          </a:p>
+          <a:p>
+            <a:pPr algn="l">
+              <a:lnSpc>
+                <a:spcPct val="105000"/>
+              </a:lnSpc>
+            </a:pPr>
+            <a:r>
+              <a:rPr sz="1600" b="0">
+                <a:solidFill>
+                  <a:srgbClr val="161F37"/>
+                </a:solidFill>
+                <a:latin typeface="Arial"/>
+              </a:rPr>
+              <a:t>• One temperature knob unifies exploit / explore.</a:t>
+            </a:r>
+          </a:p>
+          <a:p>
+            <a:pPr algn="l">
+              <a:lnSpc>
+                <a:spcPct val="105000"/>
+              </a:lnSpc>
+            </a:pPr>
+            <a:r>
+              <a:rPr sz="1600" b="0">
+                <a:solidFill>
+                  <a:srgbClr val="161F37"/>
+                </a:solidFill>
+                <a:latin typeface="Arial"/>
+              </a:rPr>
+              <a:t>• Actively infers competence → curriculum by inference.</a:t>
+            </a:r>
+          </a:p>
+          <a:p>
+            <a:pPr algn="l">
+              <a:lnSpc>
+                <a:spcPct val="105000"/>
+              </a:lnSpc>
+            </a:pPr>
+            <a:r>
+              <a:rPr sz="1500" b="0">
+                <a:solidFill>
+                  <a:srgbClr val="161F37"/>
+                </a:solidFill>
+                <a:latin typeface="Arial"/>
+              </a:rPr>
+              <a:t>• Validated offline: U_K &amp; info gain peak at 0.5; belief</a:t>
+            </a:r>
+          </a:p>
+          <a:p>
+            <a:pPr algn="l">
+              <a:lnSpc>
+                <a:spcPct val="105000"/>
+              </a:lnSpc>
+            </a:pPr>
+            <a:r>
+              <a:rPr sz="1500" b="0">
+                <a:solidFill>
+                  <a:srgbClr val="161F37"/>
+                </a:solidFill>
+                <a:latin typeface="Arial"/>
+              </a:rPr>
+              <a:t>  tracks rising competence (σ 1.2→0.06, explore→exploit).</a:t>
+            </a:r>
+          </a:p>
+          <a:p>
+            <a:pPr algn="l">
+              <a:lnSpc>
+                <a:spcPct val="105000"/>
+              </a:lnSpc>
+            </a:pPr>
+            <a:r>
+              <a:rPr sz="1500" b="0">
+                <a:solidFill>
+                  <a:srgbClr val="161F37"/>
+                </a:solidFill>
+                <a:latin typeface="Arial"/>
+              </a:rPr>
+              <a:t>Honest limit: when the model outgrows d_max all levels</a:t>
+            </a:r>
+          </a:p>
+          <a:p>
+            <a:pPr algn="l">
+              <a:lnSpc>
+                <a:spcPct val="105000"/>
+              </a:lnSpc>
+            </a:pPr>
+            <a:r>
+              <a:rPr sz="1500" b="0">
+                <a:solidFill>
+                  <a:srgbClr val="161F37"/>
+                </a:solidFill>
+                <a:latin typeface="Arial"/>
+              </a:rPr>
+              <a:t>saturate → motivates environment scaling (RLVE thesis).</a:t>
+            </a:r>
+          </a:p>
+        </p:txBody>
+      </p:sp>
     </p:spTree>
     <p:extLst>
       <p:ext uri="{BB962C8B-B14F-4D97-AF65-F5344CB8AC3E}">

</xml_diff>

<commit_message>
Add all-arms RLVE results, mechanism analysis, and poster build
- results_all_arms/: 3-arm comparison (RLVE-90 / Signal / FEP), metrics + figures
- ANALYSIS.md: process-level "why" analysis (not results-only) — truncation-driven
  degenerate groups collapse the gradient; training success≈0.5 is controller-made,
  not learned; expected U_K vs realized informativeness gap; improvement directions
- diagnostics.py + diagnostics.png: held-out/truncation/entropy/success panels
- results_logs_all_arms/: raw Ray driver+worker logs backing the analysis
- poster: poster.tex + poster.pdf + assets; drop old poster_fig1.png
- retire old single-run results/ (superseded by results_all_arms/)

Co-Authored-By: Claude Opus 4.8 <noreply@anthropic.com>
</commit_message>
<xml_diff>
--- a/poster模板.pptx
+++ b/poster模板.pptx
@@ -2970,1447 +2970,84 @@
       </p:grpSpPr>
       <p:sp>
         <p:nvSpPr>
-          <p:cNvPr id="2" name="Rectangle 1"/>
-          <p:cNvSpPr/>
-          <p:nvPr/>
-        </p:nvSpPr>
-        <p:spPr>
-          <a:xfrm>
-            <a:off x="0" y="0"/>
-            <a:ext cx="21599525" cy="2834640"/>
-          </a:xfrm>
-          <a:prstGeom prst="rect">
-            <a:avLst/>
-          </a:prstGeom>
-          <a:solidFill>
-            <a:srgbClr val="0F1626"/>
-          </a:solidFill>
-          <a:ln>
-            <a:noFill/>
-          </a:ln>
-          <a:effectLst/>
-        </p:spPr>
-        <p:style>
-          <a:lnRef idx="1">
-            <a:schemeClr val="accent1"/>
-          </a:lnRef>
-          <a:fillRef idx="3">
-            <a:schemeClr val="accent1"/>
-          </a:fillRef>
-          <a:effectRef idx="2">
-            <a:schemeClr val="accent1"/>
-          </a:effectRef>
-          <a:fontRef idx="minor">
-            <a:schemeClr val="lt1"/>
-          </a:fontRef>
-        </p:style>
-        <p:txBody>
-          <a:bodyPr rtlCol="0" anchor="ctr"/>
-          <a:lstStyle/>
-          <a:p>
-            <a:pPr algn="ctr"/>
-          </a:p>
-        </p:txBody>
-      </p:sp>
-      <p:sp>
-        <p:nvSpPr>
-          <p:cNvPr id="3" name="TextBox 2"/>
-          <p:cNvSpPr txBox="1"/>
-          <p:nvPr/>
-        </p:nvSpPr>
-        <p:spPr>
-          <a:xfrm>
-            <a:off x="548640" y="320040"/>
-            <a:ext cx="20502245" cy="1371600"/>
-          </a:xfrm>
-          <a:prstGeom prst="rect">
-            <a:avLst/>
-          </a:prstGeom>
-          <a:noFill/>
-        </p:spPr>
-        <p:txBody>
-          <a:bodyPr wrap="square" anchor="t" lIns="60000" rIns="60000" tIns="30000" bIns="30000">
-            <a:spAutoFit/>
-          </a:bodyPr>
-          <a:lstStyle/>
-          <a:p>
-            <a:pPr algn="ctr">
-              <a:lnSpc>
-                <a:spcPct val="100000"/>
-              </a:lnSpc>
-            </a:pPr>
-            <a:r>
-              <a:rPr sz="4000" b="1">
-                <a:solidFill>
-                  <a:srgbClr val="FFFFFF"/>
-                </a:solidFill>
-                <a:latin typeface="Arial"/>
-              </a:rPr>
-              <a:t>FEP-RLVE: Expected-Free-Energy Difficulty Selection</a:t>
-            </a:r>
-          </a:p>
-          <a:p>
-            <a:pPr algn="ctr">
-              <a:lnSpc>
-                <a:spcPct val="100000"/>
-              </a:lnSpc>
-            </a:pPr>
-            <a:r>
-              <a:rPr sz="4000" b="1">
-                <a:solidFill>
-                  <a:srgbClr val="FFFFFF"/>
-                </a:solidFill>
-                <a:latin typeface="Arial"/>
-              </a:rPr>
-              <a:t>for Adaptive Verifiable Environments</a:t>
-            </a:r>
-          </a:p>
-        </p:txBody>
-      </p:sp>
-      <p:sp>
-        <p:nvSpPr>
-          <p:cNvPr id="4" name="TextBox 3"/>
-          <p:cNvSpPr txBox="1"/>
-          <p:nvPr/>
-        </p:nvSpPr>
-        <p:spPr>
-          <a:xfrm>
-            <a:off x="548640" y="1828800"/>
-            <a:ext cx="20502245" cy="822960"/>
-          </a:xfrm>
-          <a:prstGeom prst="rect">
-            <a:avLst/>
-          </a:prstGeom>
-          <a:noFill/>
-        </p:spPr>
-        <p:txBody>
-          <a:bodyPr wrap="square" anchor="t" lIns="60000" rIns="60000" tIns="30000" bIns="30000">
-            <a:spAutoFit/>
-          </a:bodyPr>
-          <a:lstStyle/>
-          <a:p>
-            <a:pPr algn="ctr">
-              <a:lnSpc>
-                <a:spcPct val="100000"/>
-              </a:lnSpc>
-            </a:pPr>
-            <a:r>
-              <a:rPr sz="2200" b="0">
-                <a:solidFill>
-                  <a:srgbClr val="C7CEE0"/>
-                </a:solidFill>
-                <a:latin typeface="Arial"/>
-              </a:rPr>
-              <a:t>Curriculum by inference, not by rule</a:t>
-            </a:r>
-          </a:p>
-          <a:p>
-            <a:pPr algn="ctr">
-              <a:lnSpc>
-                <a:spcPct val="100000"/>
-              </a:lnSpc>
-            </a:pPr>
-            <a:r>
-              <a:rPr sz="1600" b="0">
-                <a:solidFill>
-                  <a:srgbClr val="9BA6C2"/>
-                </a:solidFill>
-                <a:latin typeface="Arial"/>
-              </a:rPr>
-              <a:t>〈Your Name〉  ·  RL for LLM Reasoning with Environment Scaling  ·  baseline: RLVE (arXiv:2511.07317)</a:t>
-            </a:r>
-          </a:p>
-        </p:txBody>
-      </p:sp>
-      <p:sp>
-        <p:nvSpPr>
-          <p:cNvPr id="5" name="Rectangle 4"/>
-          <p:cNvSpPr/>
-          <p:nvPr/>
-        </p:nvSpPr>
-        <p:spPr>
-          <a:xfrm>
-            <a:off x="548640" y="3200400"/>
-            <a:ext cx="10022522" cy="3931920"/>
-          </a:xfrm>
-          <a:prstGeom prst="rect">
-            <a:avLst/>
-          </a:prstGeom>
-          <a:solidFill>
-            <a:srgbClr val="F4F2EE"/>
-          </a:solidFill>
-          <a:ln w="12700">
-            <a:solidFill>
-              <a:srgbClr val="D9D9D9"/>
-            </a:solidFill>
-          </a:ln>
-          <a:effectLst/>
-        </p:spPr>
-        <p:style>
-          <a:lnRef idx="1">
-            <a:schemeClr val="accent1"/>
-          </a:lnRef>
-          <a:fillRef idx="3">
-            <a:schemeClr val="accent1"/>
-          </a:fillRef>
-          <a:effectRef idx="2">
-            <a:schemeClr val="accent1"/>
-          </a:effectRef>
-          <a:fontRef idx="minor">
-            <a:schemeClr val="lt1"/>
-          </a:fontRef>
-        </p:style>
-        <p:txBody>
-          <a:bodyPr rtlCol="0" anchor="ctr"/>
-          <a:lstStyle/>
-          <a:p>
-            <a:pPr algn="ctr"/>
-          </a:p>
-        </p:txBody>
-      </p:sp>
-      <p:sp>
-        <p:nvSpPr>
-          <p:cNvPr id="6" name="TextBox 5"/>
-          <p:cNvSpPr txBox="1"/>
-          <p:nvPr/>
-        </p:nvSpPr>
-        <p:spPr>
-          <a:xfrm>
-            <a:off x="548640" y="3310128"/>
-            <a:ext cx="10022522" cy="548640"/>
-          </a:xfrm>
-          <a:prstGeom prst="rect">
-            <a:avLst/>
-          </a:prstGeom>
-          <a:noFill/>
-        </p:spPr>
-        <p:txBody>
-          <a:bodyPr wrap="square" anchor="t" lIns="60000" rIns="60000" tIns="30000" bIns="30000">
-            <a:spAutoFit/>
-          </a:bodyPr>
-          <a:lstStyle/>
-          <a:p>
-            <a:pPr algn="l">
-              <a:lnSpc>
-                <a:spcPct val="100000"/>
-              </a:lnSpc>
-            </a:pPr>
-            <a:r>
-              <a:rPr sz="2400" b="1">
-                <a:solidFill>
-                  <a:srgbClr val="C0392B"/>
-                </a:solidFill>
-                <a:latin typeface="Arial"/>
-              </a:rPr>
-              <a:t>1 · Problem</a:t>
-            </a:r>
-          </a:p>
-        </p:txBody>
-      </p:sp>
-      <p:sp>
-        <p:nvSpPr>
-          <p:cNvPr id="7" name="TextBox 6"/>
-          <p:cNvSpPr txBox="1"/>
-          <p:nvPr/>
-        </p:nvSpPr>
-        <p:spPr>
-          <a:xfrm>
-            <a:off x="548640" y="3886200"/>
-            <a:ext cx="10022522" cy="3154680"/>
-          </a:xfrm>
-          <a:prstGeom prst="rect">
-            <a:avLst/>
-          </a:prstGeom>
-          <a:noFill/>
-        </p:spPr>
-        <p:txBody>
-          <a:bodyPr wrap="square" anchor="t" lIns="60000" rIns="60000" tIns="30000" bIns="30000">
-            <a:spAutoFit/>
-          </a:bodyPr>
-          <a:lstStyle/>
-          <a:p>
-            <a:pPr algn="l">
-              <a:lnSpc>
-                <a:spcPct val="105000"/>
-              </a:lnSpc>
-            </a:pPr>
-            <a:r>
-              <a:rPr sz="1700" b="1">
-                <a:solidFill>
-                  <a:srgbClr val="161F37"/>
-                </a:solidFill>
-                <a:latin typeface="Arial"/>
-              </a:rPr>
-              <a:t>RL stalls when difficulty drifts off the model's frontier:</a:t>
-            </a:r>
-          </a:p>
-          <a:p>
-            <a:pPr algn="l">
-              <a:lnSpc>
-                <a:spcPct val="105000"/>
-              </a:lnSpc>
-            </a:pPr>
-            <a:r>
-              <a:rPr sz="1600" b="0">
-                <a:solidFill>
-                  <a:srgbClr val="161F37"/>
-                </a:solidFill>
-                <a:latin typeface="Arial"/>
-              </a:rPr>
-              <a:t>• too easy → group all-correct → 0 gradient</a:t>
-            </a:r>
-          </a:p>
-          <a:p>
-            <a:pPr algn="l">
-              <a:lnSpc>
-                <a:spcPct val="105000"/>
-              </a:lnSpc>
-            </a:pPr>
-            <a:r>
-              <a:rPr sz="1600" b="0">
-                <a:solidFill>
-                  <a:srgbClr val="161F37"/>
-                </a:solidFill>
-                <a:latin typeface="Arial"/>
-              </a:rPr>
-              <a:t>• too hard → group all-wrong → 0 gradient</a:t>
-            </a:r>
-          </a:p>
-          <a:p>
-            <a:pPr algn="l">
-              <a:lnSpc>
-                <a:spcPct val="105000"/>
-              </a:lnSpc>
-            </a:pPr>
-            <a:r>
-              <a:rPr sz="1600" b="0">
-                <a:solidFill>
-                  <a:srgbClr val="161F37"/>
-                </a:solidFill>
-                <a:latin typeface="Arial"/>
-              </a:rPr>
-              <a:t>Signal of a K-rollout group = U_K(p)=1−p^K−(1−p)^K,</a:t>
-            </a:r>
-          </a:p>
-          <a:p>
-            <a:pPr algn="l">
-              <a:lnSpc>
-                <a:spcPct val="105000"/>
-              </a:lnSpc>
-            </a:pPr>
-            <a:r>
-              <a:rPr sz="1600" b="1">
-                <a:solidFill>
-                  <a:srgbClr val="C0392B"/>
-                </a:solidFill>
-                <a:latin typeface="Arial"/>
-              </a:rPr>
-              <a:t>maximal at success p = 0.5.</a:t>
-            </a:r>
-          </a:p>
-          <a:p>
-            <a:pPr algn="l">
-              <a:lnSpc>
-                <a:spcPct val="105000"/>
-              </a:lnSpc>
-            </a:pPr>
-            <a:r>
-              <a:rPr sz="1600" b="0">
-                <a:solidFill>
-                  <a:srgbClr val="161F37"/>
-                </a:solidFill>
-                <a:latin typeface="Arial"/>
-              </a:rPr>
-              <a:t>RLVE raises difficulty only at acc ≥ 0.9 → sits at</a:t>
-            </a:r>
-          </a:p>
-          <a:p>
-            <a:pPr algn="l">
-              <a:lnSpc>
-                <a:spcPct val="105000"/>
-              </a:lnSpc>
-            </a:pPr>
-            <a:r>
-              <a:rPr sz="1600" b="1">
-                <a:solidFill>
-                  <a:srgbClr val="C0392B"/>
-                </a:solidFill>
-                <a:latin typeface="Arial"/>
-              </a:rPr>
-              <a:t>U_K(0.9)≈0.57 ≪ U_K(0.5)≈0.99 : a low-signal regime.</a:t>
-            </a:r>
-          </a:p>
-        </p:txBody>
-      </p:sp>
-      <p:sp>
-        <p:nvSpPr>
-          <p:cNvPr id="8" name="Rectangle 7"/>
-          <p:cNvSpPr/>
-          <p:nvPr/>
-        </p:nvSpPr>
-        <p:spPr>
-          <a:xfrm>
-            <a:off x="548640" y="7498080"/>
-            <a:ext cx="10022522" cy="5120640"/>
-          </a:xfrm>
-          <a:prstGeom prst="rect">
-            <a:avLst/>
-          </a:prstGeom>
-          <a:solidFill>
-            <a:srgbClr val="F4F2EE"/>
-          </a:solidFill>
-          <a:ln w="12700">
-            <a:solidFill>
-              <a:srgbClr val="D9D9D9"/>
-            </a:solidFill>
-          </a:ln>
-          <a:effectLst/>
-        </p:spPr>
-        <p:style>
-          <a:lnRef idx="1">
-            <a:schemeClr val="accent1"/>
-          </a:lnRef>
-          <a:fillRef idx="3">
-            <a:schemeClr val="accent1"/>
-          </a:fillRef>
-          <a:effectRef idx="2">
-            <a:schemeClr val="accent1"/>
-          </a:effectRef>
-          <a:fontRef idx="minor">
-            <a:schemeClr val="lt1"/>
-          </a:fontRef>
-        </p:style>
-        <p:txBody>
-          <a:bodyPr rtlCol="0" anchor="ctr"/>
-          <a:lstStyle/>
-          <a:p>
-            <a:pPr algn="ctr"/>
-          </a:p>
-        </p:txBody>
-      </p:sp>
-      <p:sp>
-        <p:nvSpPr>
-          <p:cNvPr id="9" name="TextBox 8"/>
-          <p:cNvSpPr txBox="1"/>
-          <p:nvPr/>
-        </p:nvSpPr>
-        <p:spPr>
-          <a:xfrm>
-            <a:off x="548640" y="7607808"/>
-            <a:ext cx="10022522" cy="548640"/>
-          </a:xfrm>
-          <a:prstGeom prst="rect">
-            <a:avLst/>
-          </a:prstGeom>
-          <a:noFill/>
-        </p:spPr>
-        <p:txBody>
-          <a:bodyPr wrap="square" anchor="t" lIns="60000" rIns="60000" tIns="30000" bIns="30000">
-            <a:spAutoFit/>
-          </a:bodyPr>
-          <a:lstStyle/>
-          <a:p>
-            <a:pPr algn="l">
-              <a:lnSpc>
-                <a:spcPct val="100000"/>
-              </a:lnSpc>
-            </a:pPr>
-            <a:r>
-              <a:rPr sz="2400" b="1">
-                <a:solidFill>
-                  <a:srgbClr val="C0392B"/>
-                </a:solidFill>
-                <a:latin typeface="Arial"/>
-              </a:rPr>
-              <a:t>2 · Method — minimize Expected Free Energy</a:t>
-            </a:r>
-          </a:p>
-        </p:txBody>
-      </p:sp>
-      <p:sp>
-        <p:nvSpPr>
-          <p:cNvPr id="10" name="TextBox 9"/>
-          <p:cNvSpPr txBox="1"/>
-          <p:nvPr/>
-        </p:nvSpPr>
-        <p:spPr>
-          <a:xfrm>
-            <a:off x="548640" y="8183880"/>
-            <a:ext cx="10022522" cy="4343400"/>
-          </a:xfrm>
-          <a:prstGeom prst="rect">
-            <a:avLst/>
-          </a:prstGeom>
-          <a:noFill/>
-        </p:spPr>
-        <p:txBody>
-          <a:bodyPr wrap="square" anchor="t" lIns="60000" rIns="60000" tIns="30000" bIns="30000">
-            <a:spAutoFit/>
-          </a:bodyPr>
-          <a:lstStyle/>
-          <a:p>
-            <a:pPr algn="l">
-              <a:lnSpc>
-                <a:spcPct val="105000"/>
-              </a:lnSpc>
-            </a:pPr>
-            <a:r>
-              <a:rPr sz="1600" b="1">
-                <a:solidFill>
-                  <a:srgbClr val="161F37"/>
-                </a:solidFill>
-                <a:latin typeface="Arial"/>
-              </a:rPr>
-              <a:t>Treat 'which difficulty to train on' as ACTION SELECTION</a:t>
-            </a:r>
-          </a:p>
-          <a:p>
-            <a:pPr algn="l">
-              <a:lnSpc>
-                <a:spcPct val="105000"/>
-              </a:lnSpc>
-            </a:pPr>
-            <a:r>
-              <a:rPr sz="1500" b="0">
-                <a:solidFill>
-                  <a:srgbClr val="161F37"/>
-                </a:solidFill>
-                <a:latin typeface="Arial"/>
-              </a:rPr>
-              <a:t>under the Free Energy Principle. Keep a belief q(s) over</a:t>
-            </a:r>
-          </a:p>
-          <a:p>
-            <a:pPr algn="l">
-              <a:lnSpc>
-                <a:spcPct val="105000"/>
-              </a:lnSpc>
-            </a:pPr>
-            <a:r>
-              <a:rPr sz="1500" b="0">
-                <a:solidFill>
-                  <a:srgbClr val="161F37"/>
-                </a:solidFill>
-                <a:latin typeface="Arial"/>
-              </a:rPr>
-              <a:t>the model's latent competence; pick d by minimizing EFE:</a:t>
-            </a:r>
-          </a:p>
-          <a:p>
-            <a:pPr algn="l">
-              <a:lnSpc>
-                <a:spcPct val="105000"/>
-              </a:lnSpc>
-            </a:pPr>
-            <a:r>
-              <a:rPr sz="1600" b="1">
-                <a:solidFill>
-                  <a:srgbClr val="2C6E8F"/>
-                </a:solidFill>
-                <a:latin typeface="Arial"/>
-              </a:rPr>
-              <a:t>  G(d) = −λ_sig·U_K(p̂) − λ_info·I(s;o|d) + λ_cost·C(d)</a:t>
-            </a:r>
-          </a:p>
-          <a:p>
-            <a:pPr algn="l">
-              <a:lnSpc>
-                <a:spcPct val="105000"/>
-              </a:lnSpc>
-            </a:pPr>
-            <a:r>
-              <a:rPr sz="1600" b="1">
-                <a:solidFill>
-                  <a:srgbClr val="2C6E8F"/>
-                </a:solidFill>
-                <a:latin typeface="Arial"/>
-              </a:rPr>
-              <a:t>  π(d) ∝ exp(−G(d)/T)</a:t>
-            </a:r>
-          </a:p>
-          <a:p>
-            <a:pPr algn="l">
-              <a:lnSpc>
-                <a:spcPct val="105000"/>
-              </a:lnSpc>
-            </a:pPr>
-            <a:r>
-              <a:rPr sz="1500" b="1">
-                <a:solidFill>
-                  <a:srgbClr val="C0392B"/>
-                </a:solidFill>
-                <a:latin typeface="Arial"/>
-              </a:rPr>
-              <a:t>pragmatic U_K : the DAPO learning signal (peak 0.5)</a:t>
-            </a:r>
-          </a:p>
-          <a:p>
-            <a:pPr algn="l">
-              <a:lnSpc>
-                <a:spcPct val="105000"/>
-              </a:lnSpc>
-            </a:pPr>
-            <a:r>
-              <a:rPr sz="1500" b="1">
-                <a:solidFill>
-                  <a:srgbClr val="2C6E8F"/>
-                </a:solidFill>
-                <a:latin typeface="Arial"/>
-              </a:rPr>
-              <a:t>epistemic I(s;o|d): info gain about competence (peak 0.5)</a:t>
-            </a:r>
-          </a:p>
-          <a:p>
-            <a:pPr algn="l">
-              <a:lnSpc>
-                <a:spcPct val="105000"/>
-              </a:lnSpc>
-            </a:pPr>
-            <a:r>
-              <a:rPr sz="1500" b="0">
-                <a:solidFill>
-                  <a:srgbClr val="161F37"/>
-                </a:solidFill>
-                <a:latin typeface="Arial"/>
-              </a:rPr>
-              <a:t>T→0 ⇒ hard set-point at optimal 0.5 (vs RLVE's 0.9);</a:t>
-            </a:r>
-          </a:p>
-          <a:p>
-            <a:pPr algn="l">
-              <a:lnSpc>
-                <a:spcPct val="105000"/>
-              </a:lnSpc>
-            </a:pPr>
-            <a:r>
-              <a:rPr sz="1500" b="0">
-                <a:solidFill>
-                  <a:srgbClr val="161F37"/>
-                </a:solidFill>
-                <a:latin typeface="Arial"/>
-              </a:rPr>
-              <a:t>uncertain belief ⇒ explore; localized ⇒ exploit (auto).</a:t>
-            </a:r>
-          </a:p>
-          <a:p>
-            <a:pPr algn="l">
-              <a:lnSpc>
-                <a:spcPct val="105000"/>
-              </a:lnSpc>
-            </a:pPr>
-            <a:r>
-              <a:rPr sz="1500" b="0">
-                <a:solidFill>
-                  <a:srgbClr val="161F37"/>
-                </a:solidFill>
-                <a:latin typeface="Arial"/>
-              </a:rPr>
-              <a:t>IRT belief σ(a(s−d)), Bayesian update each rollout.</a:t>
-            </a:r>
-          </a:p>
-        </p:txBody>
-      </p:sp>
-      <p:sp>
-        <p:nvSpPr>
-          <p:cNvPr id="11" name="Rectangle 10"/>
-          <p:cNvSpPr/>
-          <p:nvPr/>
-        </p:nvSpPr>
-        <p:spPr>
-          <a:xfrm>
-            <a:off x="548640" y="12984480"/>
-            <a:ext cx="10022522" cy="3840480"/>
-          </a:xfrm>
-          <a:prstGeom prst="rect">
-            <a:avLst/>
-          </a:prstGeom>
-          <a:solidFill>
-            <a:srgbClr val="F4F2EE"/>
-          </a:solidFill>
-          <a:ln w="12700">
-            <a:solidFill>
-              <a:srgbClr val="D9D9D9"/>
-            </a:solidFill>
-          </a:ln>
-          <a:effectLst/>
-        </p:spPr>
-        <p:style>
-          <a:lnRef idx="1">
-            <a:schemeClr val="accent1"/>
-          </a:lnRef>
-          <a:fillRef idx="3">
-            <a:schemeClr val="accent1"/>
-          </a:fillRef>
-          <a:effectRef idx="2">
-            <a:schemeClr val="accent1"/>
-          </a:effectRef>
-          <a:fontRef idx="minor">
-            <a:schemeClr val="lt1"/>
-          </a:fontRef>
-        </p:style>
-        <p:txBody>
-          <a:bodyPr rtlCol="0" anchor="ctr"/>
-          <a:lstStyle/>
-          <a:p>
-            <a:pPr algn="ctr"/>
-          </a:p>
-        </p:txBody>
-      </p:sp>
-      <p:sp>
-        <p:nvSpPr>
-          <p:cNvPr id="12" name="TextBox 11"/>
-          <p:cNvSpPr txBox="1"/>
-          <p:nvPr/>
-        </p:nvSpPr>
-        <p:spPr>
-          <a:xfrm>
-            <a:off x="548640" y="13094208"/>
-            <a:ext cx="10022522" cy="548640"/>
-          </a:xfrm>
-          <a:prstGeom prst="rect">
-            <a:avLst/>
-          </a:prstGeom>
-          <a:noFill/>
-        </p:spPr>
-        <p:txBody>
-          <a:bodyPr wrap="square" anchor="t" lIns="60000" rIns="60000" tIns="30000" bIns="30000">
-            <a:spAutoFit/>
-          </a:bodyPr>
-          <a:lstStyle/>
-          <a:p>
-            <a:pPr algn="l">
-              <a:lnSpc>
-                <a:spcPct val="100000"/>
-              </a:lnSpc>
-            </a:pPr>
-            <a:r>
-              <a:rPr sz="2400" b="1">
-                <a:solidFill>
-                  <a:srgbClr val="C0392B"/>
-                </a:solidFill>
-                <a:latin typeface="Arial"/>
-              </a:rPr>
-              <a:t>3 · Setup</a:t>
-            </a:r>
-          </a:p>
-        </p:txBody>
-      </p:sp>
-      <p:sp>
-        <p:nvSpPr>
-          <p:cNvPr id="13" name="TextBox 12"/>
-          <p:cNvSpPr txBox="1"/>
-          <p:nvPr/>
-        </p:nvSpPr>
-        <p:spPr>
-          <a:xfrm>
-            <a:off x="548640" y="13670280"/>
-            <a:ext cx="10022522" cy="3063240"/>
-          </a:xfrm>
-          <a:prstGeom prst="rect">
-            <a:avLst/>
-          </a:prstGeom>
-          <a:noFill/>
-        </p:spPr>
-        <p:txBody>
-          <a:bodyPr wrap="square" anchor="t" lIns="60000" rIns="60000" tIns="30000" bIns="30000">
-            <a:spAutoFit/>
-          </a:bodyPr>
-          <a:lstStyle/>
-          <a:p>
-            <a:pPr algn="l">
-              <a:lnSpc>
-                <a:spcPct val="105000"/>
-              </a:lnSpc>
-            </a:pPr>
-            <a:r>
-              <a:rPr sz="1600" b="1">
-                <a:solidFill>
-                  <a:srgbClr val="161F37"/>
-                </a:solidFill>
-                <a:latin typeface="Arial"/>
-              </a:rPr>
-              <a:t>Reproduce RLVE (SLIME) from ProRL-1.5B-v2, single H200.</a:t>
-            </a:r>
-          </a:p>
-          <a:p>
-            <a:pPr algn="l">
-              <a:lnSpc>
-                <a:spcPct val="105000"/>
-              </a:lnSpc>
-            </a:pPr>
-            <a:r>
-              <a:rPr sz="1500" b="0">
-                <a:solidFill>
-                  <a:srgbClr val="161F37"/>
-                </a:solidFill>
-                <a:latin typeface="Arial"/>
-              </a:rPr>
-              <a:t>RLVE-Gym verifiable envs + held-out envs. Same model,</a:t>
-            </a:r>
-          </a:p>
-          <a:p>
-            <a:pPr algn="l">
-              <a:lnSpc>
-                <a:spcPct val="105000"/>
-              </a:lnSpc>
-            </a:pPr>
-            <a:r>
-              <a:rPr sz="1500" b="0">
-                <a:solidFill>
-                  <a:srgbClr val="161F37"/>
-                </a:solidFill>
-                <a:latin typeface="Arial"/>
-              </a:rPr>
-              <a:t>compute, RL algo (DAPO); only the difficulty sampler differs.</a:t>
-            </a:r>
-          </a:p>
-          <a:p>
-            <a:pPr algn="l">
-              <a:lnSpc>
-                <a:spcPct val="105000"/>
-              </a:lnSpc>
-            </a:pPr>
-            <a:r>
-              <a:rPr sz="1500" b="0">
-                <a:solidFill>
-                  <a:srgbClr val="161F37"/>
-                </a:solidFill>
-                <a:latin typeface="Arial"/>
-              </a:rPr>
-              <a:t>Drop-in controller switched by DIFFICULTY_MODE; default</a:t>
-            </a:r>
-          </a:p>
-          <a:p>
-            <a:pPr algn="l">
-              <a:lnSpc>
-                <a:spcPct val="105000"/>
-              </a:lnSpc>
-            </a:pPr>
-            <a:r>
-              <a:rPr sz="1500" b="0">
-                <a:solidFill>
-                  <a:srgbClr val="161F37"/>
-                </a:solidFill>
-                <a:latin typeface="Arial"/>
-              </a:rPr>
-              <a:t>behavior is byte-for-byte RLVE.</a:t>
-            </a:r>
-          </a:p>
-        </p:txBody>
-      </p:sp>
-      <p:sp>
-        <p:nvSpPr>
-          <p:cNvPr id="14" name="Rectangle 13"/>
-          <p:cNvSpPr/>
-          <p:nvPr/>
-        </p:nvSpPr>
-        <p:spPr>
-          <a:xfrm>
-            <a:off x="11028362" y="3200400"/>
-            <a:ext cx="10022522" cy="4572000"/>
-          </a:xfrm>
-          <a:prstGeom prst="rect">
-            <a:avLst/>
-          </a:prstGeom>
-          <a:solidFill>
-            <a:srgbClr val="FFFFFF"/>
-          </a:solidFill>
-          <a:ln w="12700">
-            <a:solidFill>
-              <a:srgbClr val="D9D9D9"/>
-            </a:solidFill>
-          </a:ln>
-          <a:effectLst/>
-        </p:spPr>
-        <p:style>
-          <a:lnRef idx="1">
-            <a:schemeClr val="accent1"/>
-          </a:lnRef>
-          <a:fillRef idx="3">
-            <a:schemeClr val="accent1"/>
-          </a:fillRef>
-          <a:effectRef idx="2">
-            <a:schemeClr val="accent1"/>
-          </a:effectRef>
-          <a:fontRef idx="minor">
-            <a:schemeClr val="lt1"/>
-          </a:fontRef>
-        </p:style>
-        <p:txBody>
-          <a:bodyPr rtlCol="0" anchor="ctr"/>
-          <a:lstStyle/>
-          <a:p>
-            <a:pPr algn="ctr"/>
-          </a:p>
-        </p:txBody>
-      </p:sp>
-      <p:sp>
-        <p:nvSpPr>
-          <p:cNvPr id="15" name="TextBox 14"/>
-          <p:cNvSpPr txBox="1"/>
-          <p:nvPr/>
-        </p:nvSpPr>
-        <p:spPr>
-          <a:xfrm>
-            <a:off x="11028362" y="3310128"/>
-            <a:ext cx="10022522" cy="548640"/>
-          </a:xfrm>
-          <a:prstGeom prst="rect">
-            <a:avLst/>
-          </a:prstGeom>
-          <a:noFill/>
-        </p:spPr>
-        <p:txBody>
-          <a:bodyPr wrap="square" anchor="t" lIns="60000" rIns="60000" tIns="30000" bIns="30000">
-            <a:spAutoFit/>
-          </a:bodyPr>
-          <a:lstStyle/>
-          <a:p>
-            <a:pPr algn="l">
-              <a:lnSpc>
-                <a:spcPct val="100000"/>
-              </a:lnSpc>
-            </a:pPr>
-            <a:r>
-              <a:rPr sz="2400" b="1">
-                <a:solidFill>
-                  <a:srgbClr val="C0392B"/>
-                </a:solidFill>
-                <a:latin typeface="Arial"/>
-              </a:rPr>
-              <a:t>Key idea: both signals peak at p = 0.5</a:t>
-            </a:r>
+          <p:cNvPr id="2" name="标题 1">
+            <a:extLst>
+              <a:ext uri="{FF2B5EF4-FFF2-40B4-BE49-F238E27FC236}">
+                <a16:creationId xmlns:a16="http://schemas.microsoft.com/office/drawing/2014/main" id="{9F1021FD-3383-751E-28F4-5304CC8A7DA7}"/>
+              </a:ext>
+            </a:extLst>
+          </p:cNvPr>
+          <p:cNvSpPr>
+            <a:spLocks noGrp="1"/>
+          </p:cNvSpPr>
+          <p:nvPr>
+            <p:ph type="ctrTitle"/>
+          </p:nvPr>
+        </p:nvSpPr>
+        <p:spPr/>
+        <p:txBody>
+          <a:bodyPr/>
+          <a:lstStyle/>
+          <a:p>
+            <a:endParaRPr kumimoji="1" lang="zh-CN" altLang="en-US"/>
+          </a:p>
+        </p:txBody>
+      </p:sp>
+      <p:sp>
+        <p:nvSpPr>
+          <p:cNvPr id="3" name="副标题 2">
+            <a:extLst>
+              <a:ext uri="{FF2B5EF4-FFF2-40B4-BE49-F238E27FC236}">
+                <a16:creationId xmlns:a16="http://schemas.microsoft.com/office/drawing/2014/main" id="{89D4A7D4-30C4-F7B7-7AE4-12881F5E924D}"/>
+              </a:ext>
+            </a:extLst>
+          </p:cNvPr>
+          <p:cNvSpPr>
+            <a:spLocks noGrp="1"/>
+          </p:cNvSpPr>
+          <p:nvPr>
+            <p:ph type="subTitle" idx="1"/>
+          </p:nvPr>
+        </p:nvSpPr>
+        <p:spPr/>
+        <p:txBody>
+          <a:bodyPr/>
+          <a:lstStyle/>
+          <a:p>
+            <a:endParaRPr kumimoji="1" lang="zh-CN" altLang="en-US"/>
           </a:p>
         </p:txBody>
       </p:sp>
       <p:pic>
         <p:nvPicPr>
-          <p:cNvPr id="16" name="Picture 15" descr="poster_fig1.png"/>
+          <p:cNvPr id="5" name="图片 4" descr="形状&#10;&#10;中度可信度描述已自动生成">
+            <a:extLst>
+              <a:ext uri="{FF2B5EF4-FFF2-40B4-BE49-F238E27FC236}">
+                <a16:creationId xmlns:a16="http://schemas.microsoft.com/office/drawing/2014/main" id="{85F2C7CD-D641-AD77-DC02-00B782104AB8}"/>
+              </a:ext>
+            </a:extLst>
+          </p:cNvPr>
           <p:cNvPicPr>
             <a:picLocks noChangeAspect="1"/>
           </p:cNvPicPr>
           <p:nvPr/>
         </p:nvPicPr>
         <p:blipFill>
-          <a:blip r:embed="rId3"/>
+          <a:blip r:embed="rId2"/>
           <a:stretch>
             <a:fillRect/>
           </a:stretch>
         </p:blipFill>
         <p:spPr>
           <a:xfrm>
-            <a:off x="11256962" y="3931920"/>
-            <a:ext cx="9565322" cy="5579771"/>
+            <a:off x="-1" y="0"/>
+            <a:ext cx="21599525" cy="32399288"/>
           </a:xfrm>
           <a:prstGeom prst="rect">
             <a:avLst/>
           </a:prstGeom>
         </p:spPr>
       </p:pic>
-      <p:sp>
-        <p:nvSpPr>
-          <p:cNvPr id="17" name="Rectangle 16"/>
-          <p:cNvSpPr/>
-          <p:nvPr/>
-        </p:nvSpPr>
-        <p:spPr>
-          <a:xfrm>
-            <a:off x="11028362" y="8138160"/>
-            <a:ext cx="10022522" cy="4937760"/>
-          </a:xfrm>
-          <a:prstGeom prst="rect">
-            <a:avLst/>
-          </a:prstGeom>
-          <a:solidFill>
-            <a:srgbClr val="F4F2EE"/>
-          </a:solidFill>
-          <a:ln w="12700">
-            <a:solidFill>
-              <a:srgbClr val="D9D9D9"/>
-            </a:solidFill>
-          </a:ln>
-          <a:effectLst/>
-        </p:spPr>
-        <p:style>
-          <a:lnRef idx="1">
-            <a:schemeClr val="accent1"/>
-          </a:lnRef>
-          <a:fillRef idx="3">
-            <a:schemeClr val="accent1"/>
-          </a:fillRef>
-          <a:effectRef idx="2">
-            <a:schemeClr val="accent1"/>
-          </a:effectRef>
-          <a:fontRef idx="minor">
-            <a:schemeClr val="lt1"/>
-          </a:fontRef>
-        </p:style>
-        <p:txBody>
-          <a:bodyPr rtlCol="0" anchor="ctr"/>
-          <a:lstStyle/>
-          <a:p>
-            <a:pPr algn="ctr"/>
-          </a:p>
-        </p:txBody>
-      </p:sp>
-      <p:sp>
-        <p:nvSpPr>
-          <p:cNvPr id="18" name="TextBox 17"/>
-          <p:cNvSpPr txBox="1"/>
-          <p:nvPr/>
-        </p:nvSpPr>
-        <p:spPr>
-          <a:xfrm>
-            <a:off x="11028362" y="8247888"/>
-            <a:ext cx="10022522" cy="548640"/>
-          </a:xfrm>
-          <a:prstGeom prst="rect">
-            <a:avLst/>
-          </a:prstGeom>
-          <a:noFill/>
-        </p:spPr>
-        <p:txBody>
-          <a:bodyPr wrap="square" anchor="t" lIns="60000" rIns="60000" tIns="30000" bIns="30000">
-            <a:spAutoFit/>
-          </a:bodyPr>
-          <a:lstStyle/>
-          <a:p>
-            <a:pPr algn="l">
-              <a:lnSpc>
-                <a:spcPct val="100000"/>
-              </a:lnSpc>
-            </a:pPr>
-            <a:r>
-              <a:rPr sz="2400" b="1">
-                <a:solidFill>
-                  <a:srgbClr val="C0392B"/>
-                </a:solidFill>
-                <a:latin typeface="Arial"/>
-              </a:rPr>
-              <a:t>4 · Four-arm comparison</a:t>
-            </a:r>
-          </a:p>
-        </p:txBody>
-      </p:sp>
-      <p:sp>
-        <p:nvSpPr>
-          <p:cNvPr id="19" name="TextBox 18"/>
-          <p:cNvSpPr txBox="1"/>
-          <p:nvPr/>
-        </p:nvSpPr>
-        <p:spPr>
-          <a:xfrm>
-            <a:off x="11028362" y="8823960"/>
-            <a:ext cx="10022522" cy="4160520"/>
-          </a:xfrm>
-          <a:prstGeom prst="rect">
-            <a:avLst/>
-          </a:prstGeom>
-          <a:noFill/>
-        </p:spPr>
-        <p:txBody>
-          <a:bodyPr wrap="square" anchor="t" lIns="60000" rIns="60000" tIns="30000" bIns="30000">
-            <a:spAutoFit/>
-          </a:bodyPr>
-          <a:lstStyle/>
-          <a:p>
-            <a:pPr algn="l">
-              <a:lnSpc>
-                <a:spcPct val="105000"/>
-              </a:lnSpc>
-            </a:pPr>
-            <a:r>
-              <a:rPr sz="1500" b="0">
-                <a:solidFill>
-                  <a:srgbClr val="161F37"/>
-                </a:solidFill>
-                <a:latin typeface="Arial"/>
-              </a:rPr>
-              <a:t>Static        frozen d        → fixed difficulty fails</a:t>
-            </a:r>
-          </a:p>
-          <a:p>
-            <a:pPr algn="l">
-              <a:lnSpc>
-                <a:spcPct val="105000"/>
-              </a:lnSpc>
-            </a:pPr>
-            <a:r>
-              <a:rPr sz="1500" b="0">
-                <a:solidFill>
-                  <a:srgbClr val="161F37"/>
-                </a:solidFill>
-                <a:latin typeface="Arial"/>
-              </a:rPr>
-              <a:t>RLVE-90       raise at 0.9     → baseline (low signal)</a:t>
-            </a:r>
-          </a:p>
-          <a:p>
-            <a:pPr algn="l">
-              <a:lnSpc>
-                <a:spcPct val="105000"/>
-              </a:lnSpc>
-            </a:pPr>
-            <a:r>
-              <a:rPr sz="1500" b="0">
-                <a:solidFill>
-                  <a:srgbClr val="161F37"/>
-                </a:solidFill>
-                <a:latin typeface="Arial"/>
-              </a:rPr>
-              <a:t>Signal-RLVE   U_K only         → 0.5 band, no info gain</a:t>
-            </a:r>
-          </a:p>
-          <a:p>
-            <a:pPr algn="l">
-              <a:lnSpc>
-                <a:spcPct val="105000"/>
-              </a:lnSpc>
-            </a:pPr>
-            <a:r>
-              <a:rPr sz="1500" b="1">
-                <a:solidFill>
-                  <a:srgbClr val="C0392B"/>
-                </a:solidFill>
-                <a:latin typeface="Arial"/>
-              </a:rPr>
-              <a:t>FEP-RLVE      U_K + info + EFE → full active inference</a:t>
-            </a:r>
-          </a:p>
-          <a:p>
-            <a:pPr algn="l">
-              <a:lnSpc>
-                <a:spcPct val="105000"/>
-              </a:lnSpc>
-            </a:pPr>
-            <a:r>
-              <a:rPr sz="800" b="0">
-                <a:solidFill>
-                  <a:srgbClr val="161F37"/>
-                </a:solidFill>
-                <a:latin typeface="Arial"/>
-              </a:rPr>
-              <a:t> </a:t>
-            </a:r>
-          </a:p>
-          <a:p>
-            <a:pPr algn="l">
-              <a:lnSpc>
-                <a:spcPct val="105000"/>
-              </a:lnSpc>
-            </a:pPr>
-            <a:r>
-              <a:rPr sz="1500" b="1">
-                <a:solidFill>
-                  <a:srgbClr val="161F37"/>
-                </a:solidFill>
-                <a:latin typeface="Arial"/>
-              </a:rPr>
-              <a:t>Signal-RLVE is the key ablation: only if FEP-RLVE beats it</a:t>
-            </a:r>
-          </a:p>
-          <a:p>
-            <a:pPr algn="l">
-              <a:lnSpc>
-                <a:spcPct val="105000"/>
-              </a:lnSpc>
-            </a:pPr>
-            <a:r>
-              <a:rPr sz="1500" b="0">
-                <a:solidFill>
-                  <a:srgbClr val="161F37"/>
-                </a:solidFill>
-                <a:latin typeface="Arial"/>
-              </a:rPr>
-              <a:t>does the epistemic info-gain (the FEP core) demonstrably</a:t>
-            </a:r>
-          </a:p>
-          <a:p>
-            <a:pPr algn="l">
-              <a:lnSpc>
-                <a:spcPct val="105000"/>
-              </a:lnSpc>
-            </a:pPr>
-            <a:r>
-              <a:rPr sz="1500" b="0">
-                <a:solidFill>
-                  <a:srgbClr val="161F37"/>
-                </a:solidFill>
-                <a:latin typeface="Arial"/>
-              </a:rPr>
-              <a:t>help — not just 'replace 0.9 with 0.5'.</a:t>
-            </a:r>
-          </a:p>
-          <a:p>
-            <a:pPr algn="l">
-              <a:lnSpc>
-                <a:spcPct val="105000"/>
-              </a:lnSpc>
-            </a:pPr>
-            <a:r>
-              <a:rPr sz="800" b="0">
-                <a:solidFill>
-                  <a:srgbClr val="161F37"/>
-                </a:solidFill>
-                <a:latin typeface="Arial"/>
-              </a:rPr>
-              <a:t> </a:t>
-            </a:r>
-          </a:p>
-          <a:p>
-            <a:pPr algn="l">
-              <a:lnSpc>
-                <a:spcPct val="105000"/>
-              </a:lnSpc>
-            </a:pPr>
-            <a:r>
-              <a:rPr sz="1500" b="0">
-                <a:solidFill>
-                  <a:srgbClr val="161F37"/>
-                </a:solidFill>
-                <a:latin typeface="Arial"/>
-              </a:rPr>
-              <a:t>Metrics: effective sample ratio · competence-belief</a:t>
-            </a:r>
-          </a:p>
-          <a:p>
-            <a:pPr algn="l">
-              <a:lnSpc>
-                <a:spcPct val="105000"/>
-              </a:lnSpc>
-            </a:pPr>
-            <a:r>
-              <a:rPr sz="1500" b="0">
-                <a:solidFill>
-                  <a:srgbClr val="161F37"/>
-                </a:solidFill>
-                <a:latin typeface="Arial"/>
-              </a:rPr>
-              <a:t>trajectory · held-out generalization (before/after).</a:t>
-            </a:r>
-          </a:p>
-        </p:txBody>
-      </p:sp>
-      <p:sp>
-        <p:nvSpPr>
-          <p:cNvPr id="20" name="Rectangle 19"/>
-          <p:cNvSpPr/>
-          <p:nvPr/>
-        </p:nvSpPr>
-        <p:spPr>
-          <a:xfrm>
-            <a:off x="11028362" y="13441680"/>
-            <a:ext cx="10022522" cy="3840480"/>
-          </a:xfrm>
-          <a:prstGeom prst="rect">
-            <a:avLst/>
-          </a:prstGeom>
-          <a:solidFill>
-            <a:srgbClr val="F4F2EE"/>
-          </a:solidFill>
-          <a:ln w="12700">
-            <a:solidFill>
-              <a:srgbClr val="D9D9D9"/>
-            </a:solidFill>
-          </a:ln>
-          <a:effectLst/>
-        </p:spPr>
-        <p:style>
-          <a:lnRef idx="1">
-            <a:schemeClr val="accent1"/>
-          </a:lnRef>
-          <a:fillRef idx="3">
-            <a:schemeClr val="accent1"/>
-          </a:fillRef>
-          <a:effectRef idx="2">
-            <a:schemeClr val="accent1"/>
-          </a:effectRef>
-          <a:fontRef idx="minor">
-            <a:schemeClr val="lt1"/>
-          </a:fontRef>
-        </p:style>
-        <p:txBody>
-          <a:bodyPr rtlCol="0" anchor="ctr"/>
-          <a:lstStyle/>
-          <a:p>
-            <a:pPr algn="ctr"/>
-          </a:p>
-        </p:txBody>
-      </p:sp>
-      <p:sp>
-        <p:nvSpPr>
-          <p:cNvPr id="21" name="TextBox 20"/>
-          <p:cNvSpPr txBox="1"/>
-          <p:nvPr/>
-        </p:nvSpPr>
-        <p:spPr>
-          <a:xfrm>
-            <a:off x="11028362" y="13551408"/>
-            <a:ext cx="10022522" cy="548640"/>
-          </a:xfrm>
-          <a:prstGeom prst="rect">
-            <a:avLst/>
-          </a:prstGeom>
-          <a:noFill/>
-        </p:spPr>
-        <p:txBody>
-          <a:bodyPr wrap="square" anchor="t" lIns="60000" rIns="60000" tIns="30000" bIns="30000">
-            <a:spAutoFit/>
-          </a:bodyPr>
-          <a:lstStyle/>
-          <a:p>
-            <a:pPr algn="l">
-              <a:lnSpc>
-                <a:spcPct val="100000"/>
-              </a:lnSpc>
-            </a:pPr>
-            <a:r>
-              <a:rPr sz="2400" b="1">
-                <a:solidFill>
-                  <a:srgbClr val="C0392B"/>
-                </a:solidFill>
-                <a:latin typeface="Arial"/>
-              </a:rPr>
-              <a:t>5 · Takeaways</a:t>
-            </a:r>
-          </a:p>
-        </p:txBody>
-      </p:sp>
-      <p:sp>
-        <p:nvSpPr>
-          <p:cNvPr id="22" name="TextBox 21"/>
-          <p:cNvSpPr txBox="1"/>
-          <p:nvPr/>
-        </p:nvSpPr>
-        <p:spPr>
-          <a:xfrm>
-            <a:off x="11028362" y="14127480"/>
-            <a:ext cx="10022522" cy="3063240"/>
-          </a:xfrm>
-          <a:prstGeom prst="rect">
-            <a:avLst/>
-          </a:prstGeom>
-          <a:noFill/>
-        </p:spPr>
-        <p:txBody>
-          <a:bodyPr wrap="square" anchor="t" lIns="60000" rIns="60000" tIns="30000" bIns="30000">
-            <a:spAutoFit/>
-          </a:bodyPr>
-          <a:lstStyle/>
-          <a:p>
-            <a:pPr algn="l">
-              <a:lnSpc>
-                <a:spcPct val="105000"/>
-              </a:lnSpc>
-            </a:pPr>
-            <a:r>
-              <a:rPr sz="1600" b="1">
-                <a:solidFill>
-                  <a:srgbClr val="161F37"/>
-                </a:solidFill>
-                <a:latin typeface="Arial"/>
-              </a:rPr>
-              <a:t>• Difficulty = a control target (EFE), not a 0.9 threshold.</a:t>
-            </a:r>
-          </a:p>
-          <a:p>
-            <a:pPr algn="l">
-              <a:lnSpc>
-                <a:spcPct val="105000"/>
-              </a:lnSpc>
-            </a:pPr>
-            <a:r>
-              <a:rPr sz="1600" b="0">
-                <a:solidFill>
-                  <a:srgbClr val="161F37"/>
-                </a:solidFill>
-                <a:latin typeface="Arial"/>
-              </a:rPr>
-              <a:t>• One temperature knob unifies exploit / explore.</a:t>
-            </a:r>
-          </a:p>
-          <a:p>
-            <a:pPr algn="l">
-              <a:lnSpc>
-                <a:spcPct val="105000"/>
-              </a:lnSpc>
-            </a:pPr>
-            <a:r>
-              <a:rPr sz="1600" b="0">
-                <a:solidFill>
-                  <a:srgbClr val="161F37"/>
-                </a:solidFill>
-                <a:latin typeface="Arial"/>
-              </a:rPr>
-              <a:t>• Actively infers competence → curriculum by inference.</a:t>
-            </a:r>
-          </a:p>
-          <a:p>
-            <a:pPr algn="l">
-              <a:lnSpc>
-                <a:spcPct val="105000"/>
-              </a:lnSpc>
-            </a:pPr>
-            <a:r>
-              <a:rPr sz="1500" b="0">
-                <a:solidFill>
-                  <a:srgbClr val="161F37"/>
-                </a:solidFill>
-                <a:latin typeface="Arial"/>
-              </a:rPr>
-              <a:t>• Validated offline: U_K &amp; info gain peak at 0.5; belief</a:t>
-            </a:r>
-          </a:p>
-          <a:p>
-            <a:pPr algn="l">
-              <a:lnSpc>
-                <a:spcPct val="105000"/>
-              </a:lnSpc>
-            </a:pPr>
-            <a:r>
-              <a:rPr sz="1500" b="0">
-                <a:solidFill>
-                  <a:srgbClr val="161F37"/>
-                </a:solidFill>
-                <a:latin typeface="Arial"/>
-              </a:rPr>
-              <a:t>  tracks rising competence (σ 1.2→0.06, explore→exploit).</a:t>
-            </a:r>
-          </a:p>
-          <a:p>
-            <a:pPr algn="l">
-              <a:lnSpc>
-                <a:spcPct val="105000"/>
-              </a:lnSpc>
-            </a:pPr>
-            <a:r>
-              <a:rPr sz="1500" b="0">
-                <a:solidFill>
-                  <a:srgbClr val="161F37"/>
-                </a:solidFill>
-                <a:latin typeface="Arial"/>
-              </a:rPr>
-              <a:t>Honest limit: when the model outgrows d_max all levels</a:t>
-            </a:r>
-          </a:p>
-          <a:p>
-            <a:pPr algn="l">
-              <a:lnSpc>
-                <a:spcPct val="105000"/>
-              </a:lnSpc>
-            </a:pPr>
-            <a:r>
-              <a:rPr sz="1500" b="0">
-                <a:solidFill>
-                  <a:srgbClr val="161F37"/>
-                </a:solidFill>
-                <a:latin typeface="Arial"/>
-              </a:rPr>
-              <a:t>saturate → motivates environment scaling (RLVE thesis).</a:t>
-            </a:r>
-          </a:p>
-        </p:txBody>
-      </p:sp>
     </p:spTree>
     <p:extLst>
       <p:ext uri="{BB962C8B-B14F-4D97-AF65-F5344CB8AC3E}">

</xml_diff>